<commit_message>
Add questionnaires to experiment plan; note app stamp rally and existing spots
Co-Authored-By: Claude Opus 5.5 <noreply@anthropic.com>
Claude-Session: https://claude.ai/code/session_01KouW72fBMSCT3ro1ARBkSw
</commit_message>
<xml_diff>
--- a/reports/Asakusa_experiment_plan.pptx
+++ b/reports/Asakusa_experiment_plan.pptx
@@ -10,6 +10,8 @@
   <p:sldIdLst>
     <p:sldId id="256" r:id="rId6"/>
     <p:sldId id="257" r:id="rId7"/>
+    <p:sldId id="277" r:id="rId27"/>
+    <p:sldId id="276" r:id="rId26"/>
     <p:sldId id="275" r:id="rId25"/>
     <p:sldId id="274" r:id="rId24"/>
     <p:sldId id="273" r:id="rId23"/>
@@ -9771,7 +9773,7 @@
                           </a:solidFill>
                           <a:latin typeface="Arial"/>
                         </a:rPr>
-                        <a:t>Given with each check-in; fills the rally card</a:t>
+                        <a:t>Stamp button on the spot page, within 200 m (built into the app)</a:t>
                       </a:r>
                     </a:p>
                   </a:txBody>
@@ -10975,7 +10977,7 @@
                 </a:solidFill>
                 <a:latin typeface="Arial"/>
               </a:rPr>
-              <a:t>Medal levels already exist in the app: Star 500, Professional 1,000</a:t>
+              <a:t>Stamp rally and medals are already built into the app; only server settings are needed</a:t>
             </a:r>
           </a:p>
         </p:txBody>
@@ -15339,6 +15341,2472 @@
 </file>
 
 <file path=ppt/slides/slide19.xml><?xml version="1.0" encoding="utf-8"?>
+<p:sld xmlns:a="http://schemas.openxmlformats.org/drawingml/2006/main" xmlns:r="http://schemas.openxmlformats.org/officeDocument/2006/relationships" xmlns:mc="http://schemas.openxmlformats.org/markup-compatibility/2006" xmlns:mv="urn:schemas-microsoft-com:mac:vml" xmlns:p="http://schemas.openxmlformats.org/presentationml/2006/main" xmlns:c="http://schemas.openxmlformats.org/drawingml/2006/chart" xmlns:dgm="http://schemas.openxmlformats.org/drawingml/2006/diagram" xmlns:o="urn:schemas-microsoft-com:office:office" xmlns:v="urn:schemas-microsoft-com:vml" xmlns:pvml="urn:schemas-microsoft-com:office:powerpoint" xmlns:com="http://schemas.openxmlformats.org/drawingml/2006/compatibility" xmlns:p14="http://schemas.microsoft.com/office/powerpoint/2010/main" xmlns:p15="http://schemas.microsoft.com/office/powerpoint/2012/main" xmlns:ahyp="http://schemas.microsoft.com/office/drawing/2018/hyperlinkcolor">
+  <p:cSld>
+    <p:spTree>
+      <p:nvGrpSpPr>
+        <p:cNvPr id="50" name="Shape 50"/>
+        <p:cNvGrpSpPr/>
+        <p:nvPr/>
+      </p:nvGrpSpPr>
+      <p:grpSpPr>
+        <a:xfrm>
+          <a:off x="0" y="0"/>
+          <a:ext cx="0" cy="0"/>
+          <a:chOff x="0" y="0"/>
+          <a:chExt cx="0" cy="0"/>
+        </a:xfrm>
+      </p:grpSpPr>
+      <p:sp>
+        <p:nvSpPr>
+          <p:cNvPr id="51" name="Google Shape;51;p8"/>
+          <p:cNvSpPr txBox="1"/>
+          <p:nvPr>
+            <p:ph idx="12" type="sldNum"/>
+          </p:nvPr>
+        </p:nvSpPr>
+        <p:spPr>
+          <a:xfrm>
+            <a:off x="9074817" y="7033452"/>
+            <a:ext cx="2459482" cy="276999"/>
+          </a:xfrm>
+          <a:prstGeom prst="rect">
+            <a:avLst/>
+          </a:prstGeom>
+          <a:noFill/>
+          <a:ln>
+            <a:noFill/>
+          </a:ln>
+        </p:spPr>
+        <p:txBody>
+          <a:bodyPr anchorCtr="0" anchor="t" bIns="0" lIns="0" spcFirstLastPara="1" rIns="0" wrap="square" tIns="0">
+            <a:noAutofit/>
+          </a:bodyPr>
+          <a:lstStyle/>
+          <a:p>
+            <a:pPr indent="0" lvl="0" marL="0" rtl="0" algn="r">
+              <a:lnSpc>
+                <a:spcPct val="100000"/>
+              </a:lnSpc>
+              <a:spcBef>
+                <a:spcPts val="0"/>
+              </a:spcBef>
+              <a:spcAft>
+                <a:spcPts val="0"/>
+              </a:spcAft>
+              <a:buSzPts val="1800"/>
+              <a:buNone/>
+            </a:pPr>
+            <a:fld id="{00000000-1234-1234-1234-123412341234}" type="slidenum">
+              <a:rPr lang="en-US"/>
+              <a:t>‹#›</a:t>
+            </a:fld>
+            <a:endParaRPr/>
+          </a:p>
+        </p:txBody>
+      </p:sp>
+      <p:sp>
+        <p:nvSpPr>
+          <p:cNvPr id="52" name="Google Shape;52;p8"/>
+          <p:cNvSpPr txBox="1"/>
+          <p:nvPr/>
+        </p:nvSpPr>
+        <p:spPr>
+          <a:xfrm>
+            <a:off x="898635" y="409903"/>
+            <a:ext cx="9800000" cy="584775"/>
+          </a:xfrm>
+          <a:prstGeom prst="rect">
+            <a:avLst/>
+          </a:prstGeom>
+          <a:noFill/>
+          <a:ln>
+            <a:noFill/>
+          </a:ln>
+        </p:spPr>
+        <p:txBody>
+          <a:bodyPr anchorCtr="0" anchor="t" bIns="45700" lIns="91425" spcFirstLastPara="1" rIns="91425" wrap="square" tIns="45700">
+            <a:spAutoFit/>
+          </a:bodyPr>
+          <a:lstStyle/>
+          <a:p>
+            <a:pPr indent="0" lvl="0" marL="0" marR="0" rtl="0" algn="l">
+              <a:lnSpc>
+                <a:spcPct val="100000"/>
+              </a:lnSpc>
+              <a:spcBef>
+                <a:spcPts val="0"/>
+              </a:spcBef>
+              <a:spcAft>
+                <a:spcPts val="0"/>
+              </a:spcAft>
+              <a:buNone/>
+            </a:pPr>
+            <a:r>
+              <a:rPr b="1" i="0" lang="en-US" sz="3200" u="none" cap="none" strike="noStrike">
+                <a:solidFill>
+                  <a:srgbClr val="000000"/>
+                </a:solidFill>
+                <a:latin typeface="Arial"/>
+                <a:ea typeface="Arial"/>
+                <a:cs typeface="Arial"/>
+                <a:sym typeface="Arial"/>
+              </a:rPr>
+              <a:t>Pre-questionnaire (before the walk, 10 min)</a:t>
+            </a:r>
+            <a:endParaRPr/>
+          </a:p>
+        </p:txBody>
+      </p:sp>
+      <p:sp>
+        <p:nvSpPr>
+          <p:cNvPr id="53" name="TextBox 52"/>
+          <p:cNvSpPr txBox="1"/>
+          <p:nvPr/>
+        </p:nvSpPr>
+        <p:spPr>
+          <a:xfrm>
+            <a:off x="900000" y="1380000"/>
+            <a:ext cx="11650000" cy="450000"/>
+          </a:xfrm>
+          <a:prstGeom prst="rect">
+            <a:avLst/>
+          </a:prstGeom>
+          <a:noFill/>
+        </p:spPr>
+        <p:txBody>
+          <a:bodyPr wrap="square" anchor="t" lIns="0" rIns="0" tIns="0" bIns="0">
+            <a:spAutoFit/>
+          </a:bodyPr>
+          <a:lstStyle/>
+          <a:p>
+            <a:pPr algn="l">
+              <a:spcAft>
+                <a:spcPts val="0"/>
+              </a:spcAft>
+            </a:pPr>
+            <a:r>
+              <a:rPr sz="1500" b="0">
+                <a:solidFill>
+                  <a:srgbClr val="5A646E"/>
+                </a:solidFill>
+                <a:latin typeface="Arial"/>
+              </a:rPr>
+              <a:t>Online form (Google Forms) in Japanese and English, separate from the app. Linked to app logs by participant ID.</a:t>
+            </a:r>
+          </a:p>
+        </p:txBody>
+      </p:sp>
+      <p:sp>
+        <p:nvSpPr>
+          <p:cNvPr id="54" name="Questionnaire left"/>
+          <p:cNvSpPr/>
+          <p:nvPr/>
+        </p:nvSpPr>
+        <p:spPr>
+          <a:xfrm>
+            <a:off x="900000" y="1930000"/>
+            <a:ext cx="5650000" cy="4900000"/>
+          </a:xfrm>
+          <a:prstGeom prst="roundRect">
+            <a:avLst>
+              <a:gd name="adj" fmla="val 6000"/>
+            </a:avLst>
+          </a:prstGeom>
+          <a:solidFill>
+            <a:srgbClr val="E9F6F9"/>
+          </a:solidFill>
+          <a:ln>
+            <a:noFill/>
+          </a:ln>
+          <a:effectLst/>
+        </p:spPr>
+        <p:style>
+          <a:lnRef idx="1">
+            <a:schemeClr val="accent1"/>
+          </a:lnRef>
+          <a:fillRef idx="3">
+            <a:schemeClr val="accent1"/>
+          </a:fillRef>
+          <a:effectRef idx="2">
+            <a:schemeClr val="accent1"/>
+          </a:effectRef>
+          <a:fontRef idx="minor">
+            <a:schemeClr val="lt1"/>
+          </a:fontRef>
+        </p:style>
+        <p:txBody>
+          <a:bodyPr rtlCol="0" anchor="ctr"/>
+          <a:lstStyle/>
+          <a:p/>
+        </p:txBody>
+      </p:sp>
+      <p:sp>
+        <p:nvSpPr>
+          <p:cNvPr id="55" name="TextBox 54"/>
+          <p:cNvSpPr txBox="1"/>
+          <p:nvPr/>
+        </p:nvSpPr>
+        <p:spPr>
+          <a:xfrm>
+            <a:off x="1160000" y="2100000"/>
+            <a:ext cx="5130000" cy="4600000"/>
+          </a:xfrm>
+          <a:prstGeom prst="rect">
+            <a:avLst/>
+          </a:prstGeom>
+          <a:noFill/>
+        </p:spPr>
+        <p:txBody>
+          <a:bodyPr wrap="square" anchor="t" lIns="0" rIns="0" tIns="0" bIns="0">
+            <a:spAutoFit/>
+          </a:bodyPr>
+          <a:lstStyle/>
+          <a:p>
+            <a:pPr algn="l">
+              <a:spcAft>
+                <a:spcPts val="800"/>
+              </a:spcAft>
+            </a:pPr>
+            <a:r>
+              <a:rPr sz="1800" b="1">
+                <a:solidFill>
+                  <a:srgbClr val="0F2F46"/>
+                </a:solidFill>
+                <a:latin typeface="Arial"/>
+              </a:rPr>
+              <a:t>A. About you</a:t>
+            </a:r>
+          </a:p>
+          <a:p>
+            <a:pPr algn="l" marL="228600" indent="-228600">
+              <a:spcAft>
+                <a:spcPts val="700"/>
+              </a:spcAft>
+              <a:buChar char="•"/>
+            </a:pPr>
+            <a:r>
+              <a:rPr sz="1600" b="0">
+                <a:solidFill>
+                  <a:srgbClr val="262B30"/>
+                </a:solidFill>
+                <a:latin typeface="Arial"/>
+              </a:rPr>
+              <a:t>Participant ID (filled in by staff)</a:t>
+            </a:r>
+          </a:p>
+          <a:p>
+            <a:pPr algn="l" marL="228600" indent="-228600">
+              <a:spcAft>
+                <a:spcPts val="700"/>
+              </a:spcAft>
+              <a:buChar char="•"/>
+            </a:pPr>
+            <a:r>
+              <a:rPr sz="1600" b="0">
+                <a:solidFill>
+                  <a:srgbClr val="262B30"/>
+                </a:solidFill>
+                <a:latin typeface="Arial"/>
+              </a:rPr>
+              <a:t>Age group: 18–19 / 20s / 30s / 40s / 50+</a:t>
+            </a:r>
+          </a:p>
+          <a:p>
+            <a:pPr algn="l" marL="228600" indent="-228600">
+              <a:spcAft>
+                <a:spcPts val="700"/>
+              </a:spcAft>
+              <a:buChar char="•"/>
+            </a:pPr>
+            <a:r>
+              <a:rPr sz="1600" b="0">
+                <a:solidFill>
+                  <a:srgbClr val="262B30"/>
+                </a:solidFill>
+                <a:latin typeface="Arial"/>
+              </a:rPr>
+              <a:t>Gender: male / female / other / prefer not to say</a:t>
+            </a:r>
+          </a:p>
+          <a:p>
+            <a:pPr algn="l" marL="228600" indent="-228600">
+              <a:spcAft>
+                <a:spcPts val="700"/>
+              </a:spcAft>
+              <a:buChar char="•"/>
+            </a:pPr>
+            <a:r>
+              <a:rPr sz="1600" b="0">
+                <a:solidFill>
+                  <a:srgbClr val="262B30"/>
+                </a:solidFill>
+                <a:latin typeface="Arial"/>
+              </a:rPr>
+              <a:t>Nationality; country or region of residence</a:t>
+            </a:r>
+          </a:p>
+          <a:p>
+            <a:pPr algn="l" marL="228600" indent="-228600">
+              <a:spcAft>
+                <a:spcPts val="700"/>
+              </a:spcAft>
+              <a:buChar char="•"/>
+            </a:pPr>
+            <a:r>
+              <a:rPr sz="1600" b="0">
+                <a:solidFill>
+                  <a:srgbClr val="262B30"/>
+                </a:solidFill>
+                <a:latin typeface="Arial"/>
+              </a:rPr>
+              <a:t>International participants: years living in Japan</a:t>
+            </a:r>
+          </a:p>
+          <a:p>
+            <a:pPr algn="l" marL="228600" indent="-228600">
+              <a:spcAft>
+                <a:spcPts val="700"/>
+              </a:spcAft>
+              <a:buChar char="•"/>
+            </a:pPr>
+            <a:r>
+              <a:rPr sz="1600" b="0">
+                <a:solidFill>
+                  <a:srgbClr val="262B30"/>
+                </a:solidFill>
+                <a:latin typeface="Arial"/>
+              </a:rPr>
+              <a:t>Smartphone: iOS / Android</a:t>
+            </a:r>
+          </a:p>
+        </p:txBody>
+      </p:sp>
+      <p:sp>
+        <p:nvSpPr>
+          <p:cNvPr id="56" name="Questionnaire right"/>
+          <p:cNvSpPr/>
+          <p:nvPr/>
+        </p:nvSpPr>
+        <p:spPr>
+          <a:xfrm>
+            <a:off x="6900000" y="1930000"/>
+            <a:ext cx="5650000" cy="4900000"/>
+          </a:xfrm>
+          <a:prstGeom prst="roundRect">
+            <a:avLst>
+              <a:gd name="adj" fmla="val 6000"/>
+            </a:avLst>
+          </a:prstGeom>
+          <a:solidFill>
+            <a:srgbClr val="FFFFFF"/>
+          </a:solidFill>
+          <a:ln w="15875">
+            <a:solidFill>
+              <a:srgbClr val="7BCFDF"/>
+            </a:solidFill>
+          </a:ln>
+          <a:effectLst/>
+        </p:spPr>
+        <p:style>
+          <a:lnRef idx="1">
+            <a:schemeClr val="accent1"/>
+          </a:lnRef>
+          <a:fillRef idx="3">
+            <a:schemeClr val="accent1"/>
+          </a:fillRef>
+          <a:effectRef idx="2">
+            <a:schemeClr val="accent1"/>
+          </a:effectRef>
+          <a:fontRef idx="minor">
+            <a:schemeClr val="lt1"/>
+          </a:fontRef>
+        </p:style>
+        <p:txBody>
+          <a:bodyPr rtlCol="0" anchor="ctr"/>
+          <a:lstStyle/>
+          <a:p/>
+        </p:txBody>
+      </p:sp>
+      <p:sp>
+        <p:nvSpPr>
+          <p:cNvPr id="57" name="TextBox 56"/>
+          <p:cNvSpPr txBox="1"/>
+          <p:nvPr/>
+        </p:nvSpPr>
+        <p:spPr>
+          <a:xfrm>
+            <a:off x="7160000" y="2100000"/>
+            <a:ext cx="5130000" cy="4600000"/>
+          </a:xfrm>
+          <a:prstGeom prst="rect">
+            <a:avLst/>
+          </a:prstGeom>
+          <a:noFill/>
+        </p:spPr>
+        <p:txBody>
+          <a:bodyPr wrap="square" anchor="t" lIns="0" rIns="0" tIns="0" bIns="0">
+            <a:spAutoFit/>
+          </a:bodyPr>
+          <a:lstStyle/>
+          <a:p>
+            <a:pPr algn="l">
+              <a:spcAft>
+                <a:spcPts val="800"/>
+              </a:spcAft>
+            </a:pPr>
+            <a:r>
+              <a:rPr sz="1800" b="1">
+                <a:solidFill>
+                  <a:srgbClr val="0F2F46"/>
+                </a:solidFill>
+                <a:latin typeface="Arial"/>
+              </a:rPr>
+              <a:t>B. Travel background</a:t>
+            </a:r>
+          </a:p>
+          <a:p>
+            <a:pPr algn="l" marL="228600" indent="-228600">
+              <a:spcAft>
+                <a:spcPts val="700"/>
+              </a:spcAft>
+              <a:buChar char="•"/>
+            </a:pPr>
+            <a:r>
+              <a:rPr sz="1600" b="0">
+                <a:solidFill>
+                  <a:srgbClr val="262B30"/>
+                </a:solidFill>
+                <a:latin typeface="Arial"/>
+              </a:rPr>
+              <a:t>Visits to Asakusa before today: 0 / 1 / 2–4 / 5+</a:t>
+            </a:r>
+          </a:p>
+          <a:p>
+            <a:pPr algn="l" marL="228600" indent="-228600">
+              <a:spcAft>
+                <a:spcPts val="700"/>
+              </a:spcAft>
+              <a:buChar char="•"/>
+            </a:pPr>
+            <a:r>
+              <a:rPr sz="1600" b="0">
+                <a:solidFill>
+                  <a:srgbClr val="262B30"/>
+                </a:solidFill>
+                <a:latin typeface="Arial"/>
+              </a:rPr>
+              <a:t>For each of the 16 checkpoints: not known / known but not visited / visited</a:t>
+            </a:r>
+          </a:p>
+          <a:p>
+            <a:pPr algn="l" marL="228600" indent="-228600">
+              <a:spcAft>
+                <a:spcPts val="700"/>
+              </a:spcAft>
+              <a:buChar char="•"/>
+            </a:pPr>
+            <a:r>
+              <a:rPr sz="1600" b="0">
+                <a:solidFill>
+                  <a:srgbClr val="262B30"/>
+                </a:solidFill>
+                <a:latin typeface="Arial"/>
+              </a:rPr>
+              <a:t>Travel motivation: sightseeing / game / reward (Kawanaka et al.)</a:t>
+            </a:r>
+          </a:p>
+          <a:p>
+            <a:pPr algn="l" marL="228600" indent="-228600">
+              <a:spcAft>
+                <a:spcPts val="700"/>
+              </a:spcAft>
+              <a:buChar char="•"/>
+            </a:pPr>
+            <a:r>
+              <a:rPr sz="1600" b="0">
+                <a:solidFill>
+                  <a:srgbClr val="262B30"/>
+                </a:solidFill>
+                <a:latin typeface="Arial"/>
+              </a:rPr>
+              <a:t>Travel style, 1–5: "I prefer famous spots" ↔ "I prefer hidden spots"</a:t>
+            </a:r>
+          </a:p>
+          <a:p>
+            <a:pPr algn="l" marL="228600" indent="-228600">
+              <a:spcAft>
+                <a:spcPts val="700"/>
+              </a:spcAft>
+              <a:buChar char="•"/>
+            </a:pPr>
+            <a:r>
+              <a:rPr sz="1600" b="0">
+                <a:solidFill>
+                  <a:srgbClr val="262B30"/>
+                </a:solidFill>
+                <a:latin typeface="Arial"/>
+              </a:rPr>
+              <a:t>"I avoid crowded tourist spots" (1–5)</a:t>
+            </a:r>
+          </a:p>
+          <a:p>
+            <a:pPr algn="l" marL="228600" indent="-228600">
+              <a:spcAft>
+                <a:spcPts val="700"/>
+              </a:spcAft>
+              <a:buChar char="•"/>
+            </a:pPr>
+            <a:r>
+              <a:rPr sz="1600" b="0">
+                <a:solidFill>
+                  <a:srgbClr val="262B30"/>
+                </a:solidFill>
+                <a:latin typeface="Arial"/>
+              </a:rPr>
+              <a:t>Use of location-based games (e.g. Pokémon GO): never / sometimes / often</a:t>
+            </a:r>
+          </a:p>
+          <a:p>
+            <a:pPr algn="l" marL="228600" indent="-228600">
+              <a:spcAft>
+                <a:spcPts val="700"/>
+              </a:spcAft>
+              <a:buChar char="•"/>
+            </a:pPr>
+            <a:r>
+              <a:rPr sz="1600" b="0">
+                <a:solidFill>
+                  <a:srgbClr val="262B30"/>
+                </a:solidFill>
+                <a:latin typeface="Arial"/>
+              </a:rPr>
+              <a:t>Use of travel apps when sightseeing: never / sometimes / often</a:t>
+            </a:r>
+          </a:p>
+        </p:txBody>
+      </p:sp>
+    </p:spTree>
+  </p:cSld>
+  <p:clrMapOvr>
+    <a:masterClrMapping/>
+  </p:clrMapOvr>
+</p:sld>
+</file>
+
+<file path=ppt/slides/slide2.xml><?xml version="1.0" encoding="utf-8"?>
+<p:sld xmlns:a="http://schemas.openxmlformats.org/drawingml/2006/main" xmlns:r="http://schemas.openxmlformats.org/officeDocument/2006/relationships" xmlns:mc="http://schemas.openxmlformats.org/markup-compatibility/2006" xmlns:mv="urn:schemas-microsoft-com:mac:vml" xmlns:p="http://schemas.openxmlformats.org/presentationml/2006/main" xmlns:c="http://schemas.openxmlformats.org/drawingml/2006/chart" xmlns:dgm="http://schemas.openxmlformats.org/drawingml/2006/diagram" xmlns:o="urn:schemas-microsoft-com:office:office" xmlns:v="urn:schemas-microsoft-com:vml" xmlns:pvml="urn:schemas-microsoft-com:office:powerpoint" xmlns:com="http://schemas.openxmlformats.org/drawingml/2006/compatibility" xmlns:p14="http://schemas.microsoft.com/office/powerpoint/2010/main" xmlns:p15="http://schemas.microsoft.com/office/powerpoint/2012/main" xmlns:ahyp="http://schemas.microsoft.com/office/drawing/2018/hyperlinkcolor">
+  <p:cSld>
+    <p:spTree>
+      <p:nvGrpSpPr>
+        <p:cNvPr id="50" name="Shape 50"/>
+        <p:cNvGrpSpPr/>
+        <p:nvPr/>
+      </p:nvGrpSpPr>
+      <p:grpSpPr>
+        <a:xfrm>
+          <a:off x="0" y="0"/>
+          <a:ext cx="0" cy="0"/>
+          <a:chOff x="0" y="0"/>
+          <a:chExt cx="0" cy="0"/>
+        </a:xfrm>
+      </p:grpSpPr>
+      <p:sp>
+        <p:nvSpPr>
+          <p:cNvPr id="51" name="Google Shape;51;p8"/>
+          <p:cNvSpPr txBox="1"/>
+          <p:nvPr>
+            <p:ph idx="12" type="sldNum"/>
+          </p:nvPr>
+        </p:nvSpPr>
+        <p:spPr>
+          <a:xfrm>
+            <a:off x="9074817" y="7033452"/>
+            <a:ext cx="2459482" cy="276999"/>
+          </a:xfrm>
+          <a:prstGeom prst="rect">
+            <a:avLst/>
+          </a:prstGeom>
+          <a:noFill/>
+          <a:ln>
+            <a:noFill/>
+          </a:ln>
+        </p:spPr>
+        <p:txBody>
+          <a:bodyPr anchorCtr="0" anchor="t" bIns="0" lIns="0" spcFirstLastPara="1" rIns="0" wrap="square" tIns="0">
+            <a:noAutofit/>
+          </a:bodyPr>
+          <a:lstStyle/>
+          <a:p>
+            <a:pPr indent="0" lvl="0" marL="0" rtl="0" algn="r">
+              <a:lnSpc>
+                <a:spcPct val="100000"/>
+              </a:lnSpc>
+              <a:spcBef>
+                <a:spcPts val="0"/>
+              </a:spcBef>
+              <a:spcAft>
+                <a:spcPts val="0"/>
+              </a:spcAft>
+              <a:buSzPts val="1800"/>
+              <a:buNone/>
+            </a:pPr>
+            <a:fld id="{00000000-1234-1234-1234-123412341234}" type="slidenum">
+              <a:rPr lang="en-US"/>
+              <a:t>‹#›</a:t>
+            </a:fld>
+            <a:endParaRPr/>
+          </a:p>
+        </p:txBody>
+      </p:sp>
+      <p:sp>
+        <p:nvSpPr>
+          <p:cNvPr id="52" name="Google Shape;52;p8"/>
+          <p:cNvSpPr txBox="1"/>
+          <p:nvPr/>
+        </p:nvSpPr>
+        <p:spPr>
+          <a:xfrm>
+            <a:off x="898635" y="409903"/>
+            <a:ext cx="9800000" cy="584775"/>
+          </a:xfrm>
+          <a:prstGeom prst="rect">
+            <a:avLst/>
+          </a:prstGeom>
+          <a:noFill/>
+          <a:ln>
+            <a:noFill/>
+          </a:ln>
+        </p:spPr>
+        <p:txBody>
+          <a:bodyPr anchorCtr="0" anchor="t" bIns="45700" lIns="91425" spcFirstLastPara="1" rIns="91425" wrap="square" tIns="45700">
+            <a:spAutoFit/>
+          </a:bodyPr>
+          <a:lstStyle/>
+          <a:p>
+            <a:pPr indent="0" lvl="0" marL="0" marR="0" rtl="0" algn="l">
+              <a:lnSpc>
+                <a:spcPct val="100000"/>
+              </a:lnSpc>
+              <a:spcBef>
+                <a:spcPts val="0"/>
+              </a:spcBef>
+              <a:spcAft>
+                <a:spcPts val="0"/>
+              </a:spcAft>
+              <a:buNone/>
+            </a:pPr>
+            <a:r>
+              <a:rPr b="1" i="0" lang="en-US" sz="3200" u="none" cap="none" strike="noStrike">
+                <a:solidFill>
+                  <a:srgbClr val="000000"/>
+                </a:solidFill>
+                <a:latin typeface="Arial"/>
+                <a:ea typeface="Arial"/>
+                <a:cs typeface="Arial"/>
+                <a:sym typeface="Arial"/>
+              </a:rPr>
+              <a:t>Table of contents</a:t>
+            </a:r>
+            <a:endParaRPr/>
+          </a:p>
+        </p:txBody>
+      </p:sp>
+      <p:sp>
+        <p:nvSpPr>
+          <p:cNvPr id="53" name="TOC number 1"/>
+          <p:cNvSpPr/>
+          <p:nvPr/>
+        </p:nvSpPr>
+        <p:spPr>
+          <a:xfrm>
+            <a:off x="900000" y="1400000"/>
+            <a:ext cx="520000" cy="520000"/>
+          </a:xfrm>
+          <a:prstGeom prst="ellipse">
+            <a:avLst/>
+          </a:prstGeom>
+          <a:solidFill>
+            <a:srgbClr val="7BCFDF"/>
+          </a:solidFill>
+          <a:ln>
+            <a:noFill/>
+          </a:ln>
+          <a:effectLst/>
+        </p:spPr>
+        <p:style>
+          <a:lnRef idx="1">
+            <a:schemeClr val="accent1"/>
+          </a:lnRef>
+          <a:fillRef idx="3">
+            <a:schemeClr val="accent1"/>
+          </a:fillRef>
+          <a:effectRef idx="2">
+            <a:schemeClr val="accent1"/>
+          </a:effectRef>
+          <a:fontRef idx="minor">
+            <a:schemeClr val="lt1"/>
+          </a:fontRef>
+        </p:style>
+        <p:txBody>
+          <a:bodyPr rtlCol="0" anchor="ctr"/>
+          <a:lstStyle/>
+          <a:p/>
+        </p:txBody>
+      </p:sp>
+      <p:sp>
+        <p:nvSpPr>
+          <p:cNvPr id="54" name="TextBox 53"/>
+          <p:cNvSpPr txBox="1"/>
+          <p:nvPr/>
+        </p:nvSpPr>
+        <p:spPr>
+          <a:xfrm>
+            <a:off x="900000" y="1400000"/>
+            <a:ext cx="520000" cy="520000"/>
+          </a:xfrm>
+          <a:prstGeom prst="rect">
+            <a:avLst/>
+          </a:prstGeom>
+          <a:noFill/>
+        </p:spPr>
+        <p:txBody>
+          <a:bodyPr wrap="square" anchor="ctr" lIns="0" rIns="0" tIns="0" bIns="0">
+            <a:spAutoFit/>
+          </a:bodyPr>
+          <a:lstStyle/>
+          <a:p>
+            <a:pPr algn="ctr">
+              <a:spcAft>
+                <a:spcPts val="0"/>
+              </a:spcAft>
+            </a:pPr>
+            <a:r>
+              <a:rPr sz="1800" b="1">
+                <a:solidFill>
+                  <a:srgbClr val="0F2F46"/>
+                </a:solidFill>
+                <a:latin typeface="Arial"/>
+              </a:rPr>
+              <a:t>1</a:t>
+            </a:r>
+          </a:p>
+        </p:txBody>
+      </p:sp>
+      <p:sp>
+        <p:nvSpPr>
+          <p:cNvPr id="55" name="TextBox 54"/>
+          <p:cNvSpPr txBox="1"/>
+          <p:nvPr/>
+        </p:nvSpPr>
+        <p:spPr>
+          <a:xfrm>
+            <a:off x="1650000" y="1400000"/>
+            <a:ext cx="9000000" cy="520000"/>
+          </a:xfrm>
+          <a:prstGeom prst="rect">
+            <a:avLst/>
+          </a:prstGeom>
+          <a:noFill/>
+        </p:spPr>
+        <p:txBody>
+          <a:bodyPr wrap="square" anchor="ctr" lIns="0" rIns="0" tIns="0" bIns="0">
+            <a:spAutoFit/>
+          </a:bodyPr>
+          <a:lstStyle/>
+          <a:p>
+            <a:pPr algn="l">
+              <a:spcAft>
+                <a:spcPts val="0"/>
+              </a:spcAft>
+            </a:pPr>
+            <a:r>
+              <a:rPr sz="2000" b="0">
+                <a:solidFill>
+                  <a:srgbClr val="262B30"/>
+                </a:solidFill>
+                <a:latin typeface="Arial"/>
+              </a:rPr>
+              <a:t>Experiment at a glance</a:t>
+            </a:r>
+          </a:p>
+        </p:txBody>
+      </p:sp>
+      <p:sp>
+        <p:nvSpPr>
+          <p:cNvPr id="56" name="TOC number 2"/>
+          <p:cNvSpPr/>
+          <p:nvPr/>
+        </p:nvSpPr>
+        <p:spPr>
+          <a:xfrm>
+            <a:off x="900000" y="1948000"/>
+            <a:ext cx="520000" cy="520000"/>
+          </a:xfrm>
+          <a:prstGeom prst="ellipse">
+            <a:avLst/>
+          </a:prstGeom>
+          <a:solidFill>
+            <a:srgbClr val="0F2F46"/>
+          </a:solidFill>
+          <a:ln>
+            <a:noFill/>
+          </a:ln>
+          <a:effectLst/>
+        </p:spPr>
+        <p:style>
+          <a:lnRef idx="1">
+            <a:schemeClr val="accent1"/>
+          </a:lnRef>
+          <a:fillRef idx="3">
+            <a:schemeClr val="accent1"/>
+          </a:fillRef>
+          <a:effectRef idx="2">
+            <a:schemeClr val="accent1"/>
+          </a:effectRef>
+          <a:fontRef idx="minor">
+            <a:schemeClr val="lt1"/>
+          </a:fontRef>
+        </p:style>
+        <p:txBody>
+          <a:bodyPr rtlCol="0" anchor="ctr"/>
+          <a:lstStyle/>
+          <a:p/>
+        </p:txBody>
+      </p:sp>
+      <p:sp>
+        <p:nvSpPr>
+          <p:cNvPr id="57" name="TextBox 56"/>
+          <p:cNvSpPr txBox="1"/>
+          <p:nvPr/>
+        </p:nvSpPr>
+        <p:spPr>
+          <a:xfrm>
+            <a:off x="900000" y="1948000"/>
+            <a:ext cx="520000" cy="520000"/>
+          </a:xfrm>
+          <a:prstGeom prst="rect">
+            <a:avLst/>
+          </a:prstGeom>
+          <a:noFill/>
+        </p:spPr>
+        <p:txBody>
+          <a:bodyPr wrap="square" anchor="ctr" lIns="0" rIns="0" tIns="0" bIns="0">
+            <a:spAutoFit/>
+          </a:bodyPr>
+          <a:lstStyle/>
+          <a:p>
+            <a:pPr algn="ctr">
+              <a:spcAft>
+                <a:spcPts val="0"/>
+              </a:spcAft>
+            </a:pPr>
+            <a:r>
+              <a:rPr sz="1800" b="1">
+                <a:solidFill>
+                  <a:srgbClr val="FFFFFF"/>
+                </a:solidFill>
+                <a:latin typeface="Arial"/>
+              </a:rPr>
+              <a:t>2</a:t>
+            </a:r>
+          </a:p>
+        </p:txBody>
+      </p:sp>
+      <p:sp>
+        <p:nvSpPr>
+          <p:cNvPr id="58" name="TextBox 57"/>
+          <p:cNvSpPr txBox="1"/>
+          <p:nvPr/>
+        </p:nvSpPr>
+        <p:spPr>
+          <a:xfrm>
+            <a:off x="1650000" y="1948000"/>
+            <a:ext cx="9000000" cy="520000"/>
+          </a:xfrm>
+          <a:prstGeom prst="rect">
+            <a:avLst/>
+          </a:prstGeom>
+          <a:noFill/>
+        </p:spPr>
+        <p:txBody>
+          <a:bodyPr wrap="square" anchor="ctr" lIns="0" rIns="0" tIns="0" bIns="0">
+            <a:spAutoFit/>
+          </a:bodyPr>
+          <a:lstStyle/>
+          <a:p>
+            <a:pPr algn="l">
+              <a:spcAft>
+                <a:spcPts val="0"/>
+              </a:spcAft>
+            </a:pPr>
+            <a:r>
+              <a:rPr sz="2000" b="0">
+                <a:solidFill>
+                  <a:srgbClr val="262B30"/>
+                </a:solidFill>
+                <a:latin typeface="Arial"/>
+              </a:rPr>
+              <a:t>Checkpoint list (16 spots)</a:t>
+            </a:r>
+          </a:p>
+        </p:txBody>
+      </p:sp>
+      <p:sp>
+        <p:nvSpPr>
+          <p:cNvPr id="59" name="TOC number 3"/>
+          <p:cNvSpPr/>
+          <p:nvPr/>
+        </p:nvSpPr>
+        <p:spPr>
+          <a:xfrm>
+            <a:off x="900000" y="2496000"/>
+            <a:ext cx="520000" cy="520000"/>
+          </a:xfrm>
+          <a:prstGeom prst="ellipse">
+            <a:avLst/>
+          </a:prstGeom>
+          <a:solidFill>
+            <a:srgbClr val="7BCFDF"/>
+          </a:solidFill>
+          <a:ln>
+            <a:noFill/>
+          </a:ln>
+          <a:effectLst/>
+        </p:spPr>
+        <p:style>
+          <a:lnRef idx="1">
+            <a:schemeClr val="accent1"/>
+          </a:lnRef>
+          <a:fillRef idx="3">
+            <a:schemeClr val="accent1"/>
+          </a:fillRef>
+          <a:effectRef idx="2">
+            <a:schemeClr val="accent1"/>
+          </a:effectRef>
+          <a:fontRef idx="minor">
+            <a:schemeClr val="lt1"/>
+          </a:fontRef>
+        </p:style>
+        <p:txBody>
+          <a:bodyPr rtlCol="0" anchor="ctr"/>
+          <a:lstStyle/>
+          <a:p/>
+        </p:txBody>
+      </p:sp>
+      <p:sp>
+        <p:nvSpPr>
+          <p:cNvPr id="60" name="TextBox 59"/>
+          <p:cNvSpPr txBox="1"/>
+          <p:nvPr/>
+        </p:nvSpPr>
+        <p:spPr>
+          <a:xfrm>
+            <a:off x="900000" y="2496000"/>
+            <a:ext cx="520000" cy="520000"/>
+          </a:xfrm>
+          <a:prstGeom prst="rect">
+            <a:avLst/>
+          </a:prstGeom>
+          <a:noFill/>
+        </p:spPr>
+        <p:txBody>
+          <a:bodyPr wrap="square" anchor="ctr" lIns="0" rIns="0" tIns="0" bIns="0">
+            <a:spAutoFit/>
+          </a:bodyPr>
+          <a:lstStyle/>
+          <a:p>
+            <a:pPr algn="ctr">
+              <a:spcAft>
+                <a:spcPts val="0"/>
+              </a:spcAft>
+            </a:pPr>
+            <a:r>
+              <a:rPr sz="1800" b="1">
+                <a:solidFill>
+                  <a:srgbClr val="0F2F46"/>
+                </a:solidFill>
+                <a:latin typeface="Arial"/>
+              </a:rPr>
+              <a:t>3</a:t>
+            </a:r>
+          </a:p>
+        </p:txBody>
+      </p:sp>
+      <p:sp>
+        <p:nvSpPr>
+          <p:cNvPr id="61" name="TextBox 60"/>
+          <p:cNvSpPr txBox="1"/>
+          <p:nvPr/>
+        </p:nvSpPr>
+        <p:spPr>
+          <a:xfrm>
+            <a:off x="1650000" y="2496000"/>
+            <a:ext cx="9000000" cy="520000"/>
+          </a:xfrm>
+          <a:prstGeom prst="rect">
+            <a:avLst/>
+          </a:prstGeom>
+          <a:noFill/>
+        </p:spPr>
+        <p:txBody>
+          <a:bodyPr wrap="square" anchor="ctr" lIns="0" rIns="0" tIns="0" bIns="0">
+            <a:spAutoFit/>
+          </a:bodyPr>
+          <a:lstStyle/>
+          <a:p>
+            <a:pPr algn="l">
+              <a:spcAft>
+                <a:spcPts val="0"/>
+              </a:spcAft>
+            </a:pPr>
+            <a:r>
+              <a:rPr sz="2000" b="0">
+                <a:solidFill>
+                  <a:srgbClr val="262B30"/>
+                </a:solidFill>
+                <a:latin typeface="Arial"/>
+              </a:rPr>
+              <a:t>Spot details</a:t>
+            </a:r>
+          </a:p>
+        </p:txBody>
+      </p:sp>
+      <p:sp>
+        <p:nvSpPr>
+          <p:cNvPr id="62" name="TOC number 4"/>
+          <p:cNvSpPr/>
+          <p:nvPr/>
+        </p:nvSpPr>
+        <p:spPr>
+          <a:xfrm>
+            <a:off x="900000" y="3044000"/>
+            <a:ext cx="520000" cy="520000"/>
+          </a:xfrm>
+          <a:prstGeom prst="ellipse">
+            <a:avLst/>
+          </a:prstGeom>
+          <a:solidFill>
+            <a:srgbClr val="0F2F46"/>
+          </a:solidFill>
+          <a:ln>
+            <a:noFill/>
+          </a:ln>
+          <a:effectLst/>
+        </p:spPr>
+        <p:style>
+          <a:lnRef idx="1">
+            <a:schemeClr val="accent1"/>
+          </a:lnRef>
+          <a:fillRef idx="3">
+            <a:schemeClr val="accent1"/>
+          </a:fillRef>
+          <a:effectRef idx="2">
+            <a:schemeClr val="accent1"/>
+          </a:effectRef>
+          <a:fontRef idx="minor">
+            <a:schemeClr val="lt1"/>
+          </a:fontRef>
+        </p:style>
+        <p:txBody>
+          <a:bodyPr rtlCol="0" anchor="ctr"/>
+          <a:lstStyle/>
+          <a:p/>
+        </p:txBody>
+      </p:sp>
+      <p:sp>
+        <p:nvSpPr>
+          <p:cNvPr id="63" name="TextBox 62"/>
+          <p:cNvSpPr txBox="1"/>
+          <p:nvPr/>
+        </p:nvSpPr>
+        <p:spPr>
+          <a:xfrm>
+            <a:off x="900000" y="3044000"/>
+            <a:ext cx="520000" cy="520000"/>
+          </a:xfrm>
+          <a:prstGeom prst="rect">
+            <a:avLst/>
+          </a:prstGeom>
+          <a:noFill/>
+        </p:spPr>
+        <p:txBody>
+          <a:bodyPr wrap="square" anchor="ctr" lIns="0" rIns="0" tIns="0" bIns="0">
+            <a:spAutoFit/>
+          </a:bodyPr>
+          <a:lstStyle/>
+          <a:p>
+            <a:pPr algn="ctr">
+              <a:spcAft>
+                <a:spcPts val="0"/>
+              </a:spcAft>
+            </a:pPr>
+            <a:r>
+              <a:rPr sz="1800" b="1">
+                <a:solidFill>
+                  <a:srgbClr val="FFFFFF"/>
+                </a:solidFill>
+                <a:latin typeface="Arial"/>
+              </a:rPr>
+              <a:t>4</a:t>
+            </a:r>
+          </a:p>
+        </p:txBody>
+      </p:sp>
+      <p:sp>
+        <p:nvSpPr>
+          <p:cNvPr id="64" name="TextBox 63"/>
+          <p:cNvSpPr txBox="1"/>
+          <p:nvPr/>
+        </p:nvSpPr>
+        <p:spPr>
+          <a:xfrm>
+            <a:off x="1650000" y="3044000"/>
+            <a:ext cx="9000000" cy="520000"/>
+          </a:xfrm>
+          <a:prstGeom prst="rect">
+            <a:avLst/>
+          </a:prstGeom>
+          <a:noFill/>
+        </p:spPr>
+        <p:txBody>
+          <a:bodyPr wrap="square" anchor="ctr" lIns="0" rIns="0" tIns="0" bIns="0">
+            <a:spAutoFit/>
+          </a:bodyPr>
+          <a:lstStyle/>
+          <a:p>
+            <a:pPr algn="l">
+              <a:spcAft>
+                <a:spcPts val="0"/>
+              </a:spcAft>
+            </a:pPr>
+            <a:r>
+              <a:rPr sz="2000" b="0">
+                <a:solidFill>
+                  <a:srgbClr val="262B30"/>
+                </a:solidFill>
+                <a:latin typeface="Arial"/>
+              </a:rPr>
+              <a:t>Points and stamp rally</a:t>
+            </a:r>
+          </a:p>
+        </p:txBody>
+      </p:sp>
+      <p:sp>
+        <p:nvSpPr>
+          <p:cNvPr id="65" name="TOC number 5"/>
+          <p:cNvSpPr/>
+          <p:nvPr/>
+        </p:nvSpPr>
+        <p:spPr>
+          <a:xfrm>
+            <a:off x="900000" y="3592000"/>
+            <a:ext cx="520000" cy="520000"/>
+          </a:xfrm>
+          <a:prstGeom prst="ellipse">
+            <a:avLst/>
+          </a:prstGeom>
+          <a:solidFill>
+            <a:srgbClr val="7BCFDF"/>
+          </a:solidFill>
+          <a:ln>
+            <a:noFill/>
+          </a:ln>
+          <a:effectLst/>
+        </p:spPr>
+        <p:style>
+          <a:lnRef idx="1">
+            <a:schemeClr val="accent1"/>
+          </a:lnRef>
+          <a:fillRef idx="3">
+            <a:schemeClr val="accent1"/>
+          </a:fillRef>
+          <a:effectRef idx="2">
+            <a:schemeClr val="accent1"/>
+          </a:effectRef>
+          <a:fontRef idx="minor">
+            <a:schemeClr val="lt1"/>
+          </a:fontRef>
+        </p:style>
+        <p:txBody>
+          <a:bodyPr rtlCol="0" anchor="ctr"/>
+          <a:lstStyle/>
+          <a:p/>
+        </p:txBody>
+      </p:sp>
+      <p:sp>
+        <p:nvSpPr>
+          <p:cNvPr id="66" name="TextBox 65"/>
+          <p:cNvSpPr txBox="1"/>
+          <p:nvPr/>
+        </p:nvSpPr>
+        <p:spPr>
+          <a:xfrm>
+            <a:off x="900000" y="3592000"/>
+            <a:ext cx="520000" cy="520000"/>
+          </a:xfrm>
+          <a:prstGeom prst="rect">
+            <a:avLst/>
+          </a:prstGeom>
+          <a:noFill/>
+        </p:spPr>
+        <p:txBody>
+          <a:bodyPr wrap="square" anchor="ctr" lIns="0" rIns="0" tIns="0" bIns="0">
+            <a:spAutoFit/>
+          </a:bodyPr>
+          <a:lstStyle/>
+          <a:p>
+            <a:pPr algn="ctr">
+              <a:spcAft>
+                <a:spcPts val="0"/>
+              </a:spcAft>
+            </a:pPr>
+            <a:r>
+              <a:rPr sz="1800" b="1">
+                <a:solidFill>
+                  <a:srgbClr val="0F2F46"/>
+                </a:solidFill>
+                <a:latin typeface="Arial"/>
+              </a:rPr>
+              <a:t>5</a:t>
+            </a:r>
+          </a:p>
+        </p:txBody>
+      </p:sp>
+      <p:sp>
+        <p:nvSpPr>
+          <p:cNvPr id="67" name="TextBox 66"/>
+          <p:cNvSpPr txBox="1"/>
+          <p:nvPr/>
+        </p:nvSpPr>
+        <p:spPr>
+          <a:xfrm>
+            <a:off x="1650000" y="3592000"/>
+            <a:ext cx="9000000" cy="520000"/>
+          </a:xfrm>
+          <a:prstGeom prst="rect">
+            <a:avLst/>
+          </a:prstGeom>
+          <a:noFill/>
+        </p:spPr>
+        <p:txBody>
+          <a:bodyPr wrap="square" anchor="ctr" lIns="0" rIns="0" tIns="0" bIns="0">
+            <a:spAutoFit/>
+          </a:bodyPr>
+          <a:lstStyle/>
+          <a:p>
+            <a:pPr algn="l">
+              <a:spcAft>
+                <a:spcPts val="0"/>
+              </a:spcAft>
+            </a:pPr>
+            <a:r>
+              <a:rPr sz="2000" b="0">
+                <a:solidFill>
+                  <a:srgbClr val="262B30"/>
+                </a:solidFill>
+                <a:latin typeface="Arial"/>
+              </a:rPr>
+              <a:t>Participant instructions</a:t>
+            </a:r>
+          </a:p>
+        </p:txBody>
+      </p:sp>
+      <p:sp>
+        <p:nvSpPr>
+          <p:cNvPr id="68" name="TOC number 6"/>
+          <p:cNvSpPr/>
+          <p:nvPr/>
+        </p:nvSpPr>
+        <p:spPr>
+          <a:xfrm>
+            <a:off x="900000" y="4140000"/>
+            <a:ext cx="520000" cy="520000"/>
+          </a:xfrm>
+          <a:prstGeom prst="ellipse">
+            <a:avLst/>
+          </a:prstGeom>
+          <a:solidFill>
+            <a:srgbClr val="0F2F46"/>
+          </a:solidFill>
+          <a:ln>
+            <a:noFill/>
+          </a:ln>
+          <a:effectLst/>
+        </p:spPr>
+        <p:style>
+          <a:lnRef idx="1">
+            <a:schemeClr val="accent1"/>
+          </a:lnRef>
+          <a:fillRef idx="3">
+            <a:schemeClr val="accent1"/>
+          </a:fillRef>
+          <a:effectRef idx="2">
+            <a:schemeClr val="accent1"/>
+          </a:effectRef>
+          <a:fontRef idx="minor">
+            <a:schemeClr val="lt1"/>
+          </a:fontRef>
+        </p:style>
+        <p:txBody>
+          <a:bodyPr rtlCol="0" anchor="ctr"/>
+          <a:lstStyle/>
+          <a:p/>
+        </p:txBody>
+      </p:sp>
+      <p:sp>
+        <p:nvSpPr>
+          <p:cNvPr id="69" name="TextBox 68"/>
+          <p:cNvSpPr txBox="1"/>
+          <p:nvPr/>
+        </p:nvSpPr>
+        <p:spPr>
+          <a:xfrm>
+            <a:off x="900000" y="4140000"/>
+            <a:ext cx="520000" cy="520000"/>
+          </a:xfrm>
+          <a:prstGeom prst="rect">
+            <a:avLst/>
+          </a:prstGeom>
+          <a:noFill/>
+        </p:spPr>
+        <p:txBody>
+          <a:bodyPr wrap="square" anchor="ctr" lIns="0" rIns="0" tIns="0" bIns="0">
+            <a:spAutoFit/>
+          </a:bodyPr>
+          <a:lstStyle/>
+          <a:p>
+            <a:pPr algn="ctr">
+              <a:spcAft>
+                <a:spcPts val="0"/>
+              </a:spcAft>
+            </a:pPr>
+            <a:r>
+              <a:rPr sz="1800" b="1">
+                <a:solidFill>
+                  <a:srgbClr val="FFFFFF"/>
+                </a:solidFill>
+                <a:latin typeface="Arial"/>
+              </a:rPr>
+              <a:t>6</a:t>
+            </a:r>
+          </a:p>
+        </p:txBody>
+      </p:sp>
+      <p:sp>
+        <p:nvSpPr>
+          <p:cNvPr id="70" name="TextBox 69"/>
+          <p:cNvSpPr txBox="1"/>
+          <p:nvPr/>
+        </p:nvSpPr>
+        <p:spPr>
+          <a:xfrm>
+            <a:off x="1650000" y="4140000"/>
+            <a:ext cx="9000000" cy="520000"/>
+          </a:xfrm>
+          <a:prstGeom prst="rect">
+            <a:avLst/>
+          </a:prstGeom>
+          <a:noFill/>
+        </p:spPr>
+        <p:txBody>
+          <a:bodyPr wrap="square" anchor="ctr" lIns="0" rIns="0" tIns="0" bIns="0">
+            <a:spAutoFit/>
+          </a:bodyPr>
+          <a:lstStyle/>
+          <a:p>
+            <a:pPr algn="l">
+              <a:spcAft>
+                <a:spcPts val="0"/>
+              </a:spcAft>
+            </a:pPr>
+            <a:r>
+              <a:rPr sz="2000" b="0">
+                <a:solidFill>
+                  <a:srgbClr val="262B30"/>
+                </a:solidFill>
+                <a:latin typeface="Arial"/>
+              </a:rPr>
+              <a:t>Schedule</a:t>
+            </a:r>
+          </a:p>
+        </p:txBody>
+      </p:sp>
+      <p:sp>
+        <p:nvSpPr>
+          <p:cNvPr id="71" name="TOC number 7"/>
+          <p:cNvSpPr/>
+          <p:nvPr/>
+        </p:nvSpPr>
+        <p:spPr>
+          <a:xfrm>
+            <a:off x="900000" y="4688000"/>
+            <a:ext cx="520000" cy="520000"/>
+          </a:xfrm>
+          <a:prstGeom prst="ellipse">
+            <a:avLst/>
+          </a:prstGeom>
+          <a:solidFill>
+            <a:srgbClr val="7BCFDF"/>
+          </a:solidFill>
+          <a:ln>
+            <a:noFill/>
+          </a:ln>
+          <a:effectLst/>
+        </p:spPr>
+        <p:style>
+          <a:lnRef idx="1">
+            <a:schemeClr val="accent1"/>
+          </a:lnRef>
+          <a:fillRef idx="3">
+            <a:schemeClr val="accent1"/>
+          </a:fillRef>
+          <a:effectRef idx="2">
+            <a:schemeClr val="accent1"/>
+          </a:effectRef>
+          <a:fontRef idx="minor">
+            <a:schemeClr val="lt1"/>
+          </a:fontRef>
+        </p:style>
+        <p:txBody>
+          <a:bodyPr rtlCol="0" anchor="ctr"/>
+          <a:lstStyle/>
+          <a:p/>
+        </p:txBody>
+      </p:sp>
+      <p:sp>
+        <p:nvSpPr>
+          <p:cNvPr id="72" name="TextBox 71"/>
+          <p:cNvSpPr txBox="1"/>
+          <p:nvPr/>
+        </p:nvSpPr>
+        <p:spPr>
+          <a:xfrm>
+            <a:off x="900000" y="4688000"/>
+            <a:ext cx="520000" cy="520000"/>
+          </a:xfrm>
+          <a:prstGeom prst="rect">
+            <a:avLst/>
+          </a:prstGeom>
+          <a:noFill/>
+        </p:spPr>
+        <p:txBody>
+          <a:bodyPr wrap="square" anchor="ctr" lIns="0" rIns="0" tIns="0" bIns="0">
+            <a:spAutoFit/>
+          </a:bodyPr>
+          <a:lstStyle/>
+          <a:p>
+            <a:pPr algn="ctr">
+              <a:spcAft>
+                <a:spcPts val="0"/>
+              </a:spcAft>
+            </a:pPr>
+            <a:r>
+              <a:rPr sz="1800" b="1">
+                <a:solidFill>
+                  <a:srgbClr val="0F2F46"/>
+                </a:solidFill>
+                <a:latin typeface="Arial"/>
+              </a:rPr>
+              <a:t>7</a:t>
+            </a:r>
+          </a:p>
+        </p:txBody>
+      </p:sp>
+      <p:sp>
+        <p:nvSpPr>
+          <p:cNvPr id="73" name="TextBox 72"/>
+          <p:cNvSpPr txBox="1"/>
+          <p:nvPr/>
+        </p:nvSpPr>
+        <p:spPr>
+          <a:xfrm>
+            <a:off x="1650000" y="4688000"/>
+            <a:ext cx="9000000" cy="520000"/>
+          </a:xfrm>
+          <a:prstGeom prst="rect">
+            <a:avLst/>
+          </a:prstGeom>
+          <a:noFill/>
+        </p:spPr>
+        <p:txBody>
+          <a:bodyPr wrap="square" anchor="ctr" lIns="0" rIns="0" tIns="0" bIns="0">
+            <a:spAutoFit/>
+          </a:bodyPr>
+          <a:lstStyle/>
+          <a:p>
+            <a:pPr algn="l">
+              <a:spcAft>
+                <a:spcPts val="0"/>
+              </a:spcAft>
+            </a:pPr>
+            <a:r>
+              <a:rPr sz="2000" b="0">
+                <a:solidFill>
+                  <a:srgbClr val="262B30"/>
+                </a:solidFill>
+                <a:latin typeface="Arial"/>
+              </a:rPr>
+              <a:t>Participants</a:t>
+            </a:r>
+          </a:p>
+        </p:txBody>
+      </p:sp>
+      <p:sp>
+        <p:nvSpPr>
+          <p:cNvPr id="74" name="TOC number 8"/>
+          <p:cNvSpPr/>
+          <p:nvPr/>
+        </p:nvSpPr>
+        <p:spPr>
+          <a:xfrm>
+            <a:off x="900000" y="5236000"/>
+            <a:ext cx="520000" cy="520000"/>
+          </a:xfrm>
+          <a:prstGeom prst="ellipse">
+            <a:avLst/>
+          </a:prstGeom>
+          <a:solidFill>
+            <a:srgbClr val="0F2F46"/>
+          </a:solidFill>
+          <a:ln>
+            <a:noFill/>
+          </a:ln>
+          <a:effectLst/>
+        </p:spPr>
+        <p:style>
+          <a:lnRef idx="1">
+            <a:schemeClr val="accent1"/>
+          </a:lnRef>
+          <a:fillRef idx="3">
+            <a:schemeClr val="accent1"/>
+          </a:fillRef>
+          <a:effectRef idx="2">
+            <a:schemeClr val="accent1"/>
+          </a:effectRef>
+          <a:fontRef idx="minor">
+            <a:schemeClr val="lt1"/>
+          </a:fontRef>
+        </p:style>
+        <p:txBody>
+          <a:bodyPr rtlCol="0" anchor="ctr"/>
+          <a:lstStyle/>
+          <a:p/>
+        </p:txBody>
+      </p:sp>
+      <p:sp>
+        <p:nvSpPr>
+          <p:cNvPr id="75" name="TextBox 74"/>
+          <p:cNvSpPr txBox="1"/>
+          <p:nvPr/>
+        </p:nvSpPr>
+        <p:spPr>
+          <a:xfrm>
+            <a:off x="900000" y="5236000"/>
+            <a:ext cx="520000" cy="520000"/>
+          </a:xfrm>
+          <a:prstGeom prst="rect">
+            <a:avLst/>
+          </a:prstGeom>
+          <a:noFill/>
+        </p:spPr>
+        <p:txBody>
+          <a:bodyPr wrap="square" anchor="ctr" lIns="0" rIns="0" tIns="0" bIns="0">
+            <a:spAutoFit/>
+          </a:bodyPr>
+          <a:lstStyle/>
+          <a:p>
+            <a:pPr algn="ctr">
+              <a:spcAft>
+                <a:spcPts val="0"/>
+              </a:spcAft>
+            </a:pPr>
+            <a:r>
+              <a:rPr sz="1800" b="1">
+                <a:solidFill>
+                  <a:srgbClr val="FFFFFF"/>
+                </a:solidFill>
+                <a:latin typeface="Arial"/>
+              </a:rPr>
+              <a:t>8</a:t>
+            </a:r>
+          </a:p>
+        </p:txBody>
+      </p:sp>
+      <p:sp>
+        <p:nvSpPr>
+          <p:cNvPr id="76" name="TextBox 75"/>
+          <p:cNvSpPr txBox="1"/>
+          <p:nvPr/>
+        </p:nvSpPr>
+        <p:spPr>
+          <a:xfrm>
+            <a:off x="1650000" y="5236000"/>
+            <a:ext cx="9000000" cy="520000"/>
+          </a:xfrm>
+          <a:prstGeom prst="rect">
+            <a:avLst/>
+          </a:prstGeom>
+          <a:noFill/>
+        </p:spPr>
+        <p:txBody>
+          <a:bodyPr wrap="square" anchor="ctr" lIns="0" rIns="0" tIns="0" bIns="0">
+            <a:spAutoFit/>
+          </a:bodyPr>
+          <a:lstStyle/>
+          <a:p>
+            <a:pPr algn="l">
+              <a:spcAft>
+                <a:spcPts val="0"/>
+              </a:spcAft>
+            </a:pPr>
+            <a:r>
+              <a:rPr sz="2000" b="0">
+                <a:solidFill>
+                  <a:srgbClr val="262B30"/>
+                </a:solidFill>
+                <a:latin typeface="Arial"/>
+              </a:rPr>
+              <a:t>Questionnaires</a:t>
+            </a:r>
+          </a:p>
+        </p:txBody>
+      </p:sp>
+      <p:sp>
+        <p:nvSpPr>
+          <p:cNvPr id="77" name="TOC number 9"/>
+          <p:cNvSpPr/>
+          <p:nvPr/>
+        </p:nvSpPr>
+        <p:spPr>
+          <a:xfrm>
+            <a:off x="900000" y="5784000"/>
+            <a:ext cx="520000" cy="520000"/>
+          </a:xfrm>
+          <a:prstGeom prst="ellipse">
+            <a:avLst/>
+          </a:prstGeom>
+          <a:solidFill>
+            <a:srgbClr val="7BCFDF"/>
+          </a:solidFill>
+          <a:ln>
+            <a:noFill/>
+          </a:ln>
+          <a:effectLst/>
+        </p:spPr>
+        <p:style>
+          <a:lnRef idx="1">
+            <a:schemeClr val="accent1"/>
+          </a:lnRef>
+          <a:fillRef idx="3">
+            <a:schemeClr val="accent1"/>
+          </a:fillRef>
+          <a:effectRef idx="2">
+            <a:schemeClr val="accent1"/>
+          </a:effectRef>
+          <a:fontRef idx="minor">
+            <a:schemeClr val="lt1"/>
+          </a:fontRef>
+        </p:style>
+        <p:txBody>
+          <a:bodyPr rtlCol="0" anchor="ctr"/>
+          <a:lstStyle/>
+          <a:p/>
+        </p:txBody>
+      </p:sp>
+      <p:sp>
+        <p:nvSpPr>
+          <p:cNvPr id="78" name="TextBox 77"/>
+          <p:cNvSpPr txBox="1"/>
+          <p:nvPr/>
+        </p:nvSpPr>
+        <p:spPr>
+          <a:xfrm>
+            <a:off x="900000" y="5784000"/>
+            <a:ext cx="520000" cy="520000"/>
+          </a:xfrm>
+          <a:prstGeom prst="rect">
+            <a:avLst/>
+          </a:prstGeom>
+          <a:noFill/>
+        </p:spPr>
+        <p:txBody>
+          <a:bodyPr wrap="square" anchor="ctr" lIns="0" rIns="0" tIns="0" bIns="0">
+            <a:spAutoFit/>
+          </a:bodyPr>
+          <a:lstStyle/>
+          <a:p>
+            <a:pPr algn="ctr">
+              <a:spcAft>
+                <a:spcPts val="0"/>
+              </a:spcAft>
+            </a:pPr>
+            <a:r>
+              <a:rPr sz="1800" b="1">
+                <a:solidFill>
+                  <a:srgbClr val="0F2F46"/>
+                </a:solidFill>
+                <a:latin typeface="Arial"/>
+              </a:rPr>
+              <a:t>9</a:t>
+            </a:r>
+          </a:p>
+        </p:txBody>
+      </p:sp>
+      <p:sp>
+        <p:nvSpPr>
+          <p:cNvPr id="79" name="TextBox 78"/>
+          <p:cNvSpPr txBox="1"/>
+          <p:nvPr/>
+        </p:nvSpPr>
+        <p:spPr>
+          <a:xfrm>
+            <a:off x="1650000" y="5784000"/>
+            <a:ext cx="9000000" cy="520000"/>
+          </a:xfrm>
+          <a:prstGeom prst="rect">
+            <a:avLst/>
+          </a:prstGeom>
+          <a:noFill/>
+        </p:spPr>
+        <p:txBody>
+          <a:bodyPr wrap="square" anchor="ctr" lIns="0" rIns="0" tIns="0" bIns="0">
+            <a:spAutoFit/>
+          </a:bodyPr>
+          <a:lstStyle/>
+          <a:p>
+            <a:pPr algn="l">
+              <a:spcAft>
+                <a:spcPts val="0"/>
+              </a:spcAft>
+            </a:pPr>
+            <a:r>
+              <a:rPr sz="2000" b="0">
+                <a:solidFill>
+                  <a:srgbClr val="262B30"/>
+                </a:solidFill>
+                <a:latin typeface="Arial"/>
+              </a:rPr>
+              <a:t>Budget</a:t>
+            </a:r>
+          </a:p>
+        </p:txBody>
+      </p:sp>
+      <p:sp>
+        <p:nvSpPr>
+          <p:cNvPr id="80" name="TOC number 10"/>
+          <p:cNvSpPr/>
+          <p:nvPr/>
+        </p:nvSpPr>
+        <p:spPr>
+          <a:xfrm>
+            <a:off x="900000" y="6332000"/>
+            <a:ext cx="520000" cy="520000"/>
+          </a:xfrm>
+          <a:prstGeom prst="ellipse">
+            <a:avLst/>
+          </a:prstGeom>
+          <a:solidFill>
+            <a:srgbClr val="0F2F46"/>
+          </a:solidFill>
+          <a:ln>
+            <a:noFill/>
+          </a:ln>
+          <a:effectLst/>
+        </p:spPr>
+        <p:style>
+          <a:lnRef idx="1">
+            <a:schemeClr val="accent1"/>
+          </a:lnRef>
+          <a:fillRef idx="3">
+            <a:schemeClr val="accent1"/>
+          </a:fillRef>
+          <a:effectRef idx="2">
+            <a:schemeClr val="accent1"/>
+          </a:effectRef>
+          <a:fontRef idx="minor">
+            <a:schemeClr val="lt1"/>
+          </a:fontRef>
+        </p:style>
+        <p:txBody>
+          <a:bodyPr rtlCol="0" anchor="ctr"/>
+          <a:lstStyle/>
+          <a:p/>
+        </p:txBody>
+      </p:sp>
+      <p:sp>
+        <p:nvSpPr>
+          <p:cNvPr id="81" name="TextBox 80"/>
+          <p:cNvSpPr txBox="1"/>
+          <p:nvPr/>
+        </p:nvSpPr>
+        <p:spPr>
+          <a:xfrm>
+            <a:off x="900000" y="6332000"/>
+            <a:ext cx="520000" cy="520000"/>
+          </a:xfrm>
+          <a:prstGeom prst="rect">
+            <a:avLst/>
+          </a:prstGeom>
+          <a:noFill/>
+        </p:spPr>
+        <p:txBody>
+          <a:bodyPr wrap="square" anchor="ctr" lIns="0" rIns="0" tIns="0" bIns="0">
+            <a:spAutoFit/>
+          </a:bodyPr>
+          <a:lstStyle/>
+          <a:p>
+            <a:pPr algn="ctr">
+              <a:spcAft>
+                <a:spcPts val="0"/>
+              </a:spcAft>
+            </a:pPr>
+            <a:r>
+              <a:rPr sz="1800" b="1">
+                <a:solidFill>
+                  <a:srgbClr val="FFFFFF"/>
+                </a:solidFill>
+                <a:latin typeface="Arial"/>
+              </a:rPr>
+              <a:t>10</a:t>
+            </a:r>
+          </a:p>
+        </p:txBody>
+      </p:sp>
+      <p:sp>
+        <p:nvSpPr>
+          <p:cNvPr id="82" name="TextBox 81"/>
+          <p:cNvSpPr txBox="1"/>
+          <p:nvPr/>
+        </p:nvSpPr>
+        <p:spPr>
+          <a:xfrm>
+            <a:off x="1650000" y="6332000"/>
+            <a:ext cx="9000000" cy="520000"/>
+          </a:xfrm>
+          <a:prstGeom prst="rect">
+            <a:avLst/>
+          </a:prstGeom>
+          <a:noFill/>
+        </p:spPr>
+        <p:txBody>
+          <a:bodyPr wrap="square" anchor="ctr" lIns="0" rIns="0" tIns="0" bIns="0">
+            <a:spAutoFit/>
+          </a:bodyPr>
+          <a:lstStyle/>
+          <a:p>
+            <a:pPr algn="l">
+              <a:spcAft>
+                <a:spcPts val="0"/>
+              </a:spcAft>
+            </a:pPr>
+            <a:r>
+              <a:rPr sz="2000" b="0">
+                <a:solidFill>
+                  <a:srgbClr val="262B30"/>
+                </a:solidFill>
+                <a:latin typeface="Arial"/>
+              </a:rPr>
+              <a:t>Items to confirm</a:t>
+            </a:r>
+          </a:p>
+        </p:txBody>
+      </p:sp>
+    </p:spTree>
+  </p:cSld>
+  <p:clrMapOvr>
+    <a:masterClrMapping/>
+  </p:clrMapOvr>
+</p:sld>
+</file>
+
+<file path=ppt/slides/slide20.xml><?xml version="1.0" encoding="utf-8"?>
+<p:sld xmlns:a="http://schemas.openxmlformats.org/drawingml/2006/main" xmlns:r="http://schemas.openxmlformats.org/officeDocument/2006/relationships" xmlns:mc="http://schemas.openxmlformats.org/markup-compatibility/2006" xmlns:mv="urn:schemas-microsoft-com:mac:vml" xmlns:p="http://schemas.openxmlformats.org/presentationml/2006/main" xmlns:c="http://schemas.openxmlformats.org/drawingml/2006/chart" xmlns:dgm="http://schemas.openxmlformats.org/drawingml/2006/diagram" xmlns:o="urn:schemas-microsoft-com:office:office" xmlns:v="urn:schemas-microsoft-com:vml" xmlns:pvml="urn:schemas-microsoft-com:office:powerpoint" xmlns:com="http://schemas.openxmlformats.org/drawingml/2006/compatibility" xmlns:p14="http://schemas.microsoft.com/office/powerpoint/2010/main" xmlns:p15="http://schemas.microsoft.com/office/powerpoint/2012/main" xmlns:ahyp="http://schemas.microsoft.com/office/drawing/2018/hyperlinkcolor">
+  <p:cSld>
+    <p:spTree>
+      <p:nvGrpSpPr>
+        <p:cNvPr id="50" name="Shape 50"/>
+        <p:cNvGrpSpPr/>
+        <p:nvPr/>
+      </p:nvGrpSpPr>
+      <p:grpSpPr>
+        <a:xfrm>
+          <a:off x="0" y="0"/>
+          <a:ext cx="0" cy="0"/>
+          <a:chOff x="0" y="0"/>
+          <a:chExt cx="0" cy="0"/>
+        </a:xfrm>
+      </p:grpSpPr>
+      <p:sp>
+        <p:nvSpPr>
+          <p:cNvPr id="51" name="Google Shape;51;p8"/>
+          <p:cNvSpPr txBox="1"/>
+          <p:nvPr>
+            <p:ph idx="12" type="sldNum"/>
+          </p:nvPr>
+        </p:nvSpPr>
+        <p:spPr>
+          <a:xfrm>
+            <a:off x="9074817" y="7033452"/>
+            <a:ext cx="2459482" cy="276999"/>
+          </a:xfrm>
+          <a:prstGeom prst="rect">
+            <a:avLst/>
+          </a:prstGeom>
+          <a:noFill/>
+          <a:ln>
+            <a:noFill/>
+          </a:ln>
+        </p:spPr>
+        <p:txBody>
+          <a:bodyPr anchorCtr="0" anchor="t" bIns="0" lIns="0" spcFirstLastPara="1" rIns="0" wrap="square" tIns="0">
+            <a:noAutofit/>
+          </a:bodyPr>
+          <a:lstStyle/>
+          <a:p>
+            <a:pPr indent="0" lvl="0" marL="0" rtl="0" algn="r">
+              <a:lnSpc>
+                <a:spcPct val="100000"/>
+              </a:lnSpc>
+              <a:spcBef>
+                <a:spcPts val="0"/>
+              </a:spcBef>
+              <a:spcAft>
+                <a:spcPts val="0"/>
+              </a:spcAft>
+              <a:buSzPts val="1800"/>
+              <a:buNone/>
+            </a:pPr>
+            <a:fld id="{00000000-1234-1234-1234-123412341234}" type="slidenum">
+              <a:rPr lang="en-US"/>
+              <a:t>‹#›</a:t>
+            </a:fld>
+            <a:endParaRPr/>
+          </a:p>
+        </p:txBody>
+      </p:sp>
+      <p:sp>
+        <p:nvSpPr>
+          <p:cNvPr id="52" name="Google Shape;52;p8"/>
+          <p:cNvSpPr txBox="1"/>
+          <p:nvPr/>
+        </p:nvSpPr>
+        <p:spPr>
+          <a:xfrm>
+            <a:off x="898635" y="409903"/>
+            <a:ext cx="9800000" cy="584775"/>
+          </a:xfrm>
+          <a:prstGeom prst="rect">
+            <a:avLst/>
+          </a:prstGeom>
+          <a:noFill/>
+          <a:ln>
+            <a:noFill/>
+          </a:ln>
+        </p:spPr>
+        <p:txBody>
+          <a:bodyPr anchorCtr="0" anchor="t" bIns="45700" lIns="91425" spcFirstLastPara="1" rIns="91425" wrap="square" tIns="45700">
+            <a:spAutoFit/>
+          </a:bodyPr>
+          <a:lstStyle/>
+          <a:p>
+            <a:pPr indent="0" lvl="0" marL="0" marR="0" rtl="0" algn="l">
+              <a:lnSpc>
+                <a:spcPct val="100000"/>
+              </a:lnSpc>
+              <a:spcBef>
+                <a:spcPts val="0"/>
+              </a:spcBef>
+              <a:spcAft>
+                <a:spcPts val="0"/>
+              </a:spcAft>
+              <a:buNone/>
+            </a:pPr>
+            <a:r>
+              <a:rPr b="1" i="0" lang="en-US" sz="3200" u="none" cap="none" strike="noStrike">
+                <a:solidFill>
+                  <a:srgbClr val="000000"/>
+                </a:solidFill>
+                <a:latin typeface="Arial"/>
+                <a:ea typeface="Arial"/>
+                <a:cs typeface="Arial"/>
+                <a:sym typeface="Arial"/>
+              </a:rPr>
+              <a:t>Post-questionnaire (after the walk, 10–15 min)</a:t>
+            </a:r>
+            <a:endParaRPr/>
+          </a:p>
+        </p:txBody>
+      </p:sp>
+      <p:sp>
+        <p:nvSpPr>
+          <p:cNvPr id="53" name="TextBox 52"/>
+          <p:cNvSpPr txBox="1"/>
+          <p:nvPr/>
+        </p:nvSpPr>
+        <p:spPr>
+          <a:xfrm>
+            <a:off x="900000" y="1380000"/>
+            <a:ext cx="11650000" cy="450000"/>
+          </a:xfrm>
+          <a:prstGeom prst="rect">
+            <a:avLst/>
+          </a:prstGeom>
+          <a:noFill/>
+        </p:spPr>
+        <p:txBody>
+          <a:bodyPr wrap="square" anchor="t" lIns="0" rIns="0" tIns="0" bIns="0">
+            <a:spAutoFit/>
+          </a:bodyPr>
+          <a:lstStyle/>
+          <a:p>
+            <a:pPr algn="l">
+              <a:spcAft>
+                <a:spcPts val="0"/>
+              </a:spcAft>
+            </a:pPr>
+            <a:r>
+              <a:rPr sz="1500" b="0">
+                <a:solidFill>
+                  <a:srgbClr val="5A646E"/>
+                </a:solidFill>
+                <a:latin typeface="Arial"/>
+              </a:rPr>
+              <a:t>Scales: 1 = strongly disagree … 5 = strongly agree. Places visited are also measured from GPS; the self-report is a cross-check.</a:t>
+            </a:r>
+          </a:p>
+        </p:txBody>
+      </p:sp>
+      <p:sp>
+        <p:nvSpPr>
+          <p:cNvPr id="54" name="Questionnaire left"/>
+          <p:cNvSpPr/>
+          <p:nvPr/>
+        </p:nvSpPr>
+        <p:spPr>
+          <a:xfrm>
+            <a:off x="900000" y="1930000"/>
+            <a:ext cx="5650000" cy="4900000"/>
+          </a:xfrm>
+          <a:prstGeom prst="roundRect">
+            <a:avLst>
+              <a:gd name="adj" fmla="val 6000"/>
+            </a:avLst>
+          </a:prstGeom>
+          <a:solidFill>
+            <a:srgbClr val="E9F6F9"/>
+          </a:solidFill>
+          <a:ln>
+            <a:noFill/>
+          </a:ln>
+          <a:effectLst/>
+        </p:spPr>
+        <p:style>
+          <a:lnRef idx="1">
+            <a:schemeClr val="accent1"/>
+          </a:lnRef>
+          <a:fillRef idx="3">
+            <a:schemeClr val="accent1"/>
+          </a:fillRef>
+          <a:effectRef idx="2">
+            <a:schemeClr val="accent1"/>
+          </a:effectRef>
+          <a:fontRef idx="minor">
+            <a:schemeClr val="lt1"/>
+          </a:fontRef>
+        </p:style>
+        <p:txBody>
+          <a:bodyPr rtlCol="0" anchor="ctr"/>
+          <a:lstStyle/>
+          <a:p/>
+        </p:txBody>
+      </p:sp>
+      <p:sp>
+        <p:nvSpPr>
+          <p:cNvPr id="55" name="TextBox 54"/>
+          <p:cNvSpPr txBox="1"/>
+          <p:nvPr/>
+        </p:nvSpPr>
+        <p:spPr>
+          <a:xfrm>
+            <a:off x="1160000" y="2100000"/>
+            <a:ext cx="5130000" cy="4600000"/>
+          </a:xfrm>
+          <a:prstGeom prst="rect">
+            <a:avLst/>
+          </a:prstGeom>
+          <a:noFill/>
+        </p:spPr>
+        <p:txBody>
+          <a:bodyPr wrap="square" anchor="t" lIns="0" rIns="0" tIns="0" bIns="0">
+            <a:spAutoFit/>
+          </a:bodyPr>
+          <a:lstStyle/>
+          <a:p>
+            <a:pPr algn="l">
+              <a:spcAft>
+                <a:spcPts val="800"/>
+              </a:spcAft>
+            </a:pPr>
+            <a:r>
+              <a:rPr sz="1800" b="1">
+                <a:solidFill>
+                  <a:srgbClr val="0F2F46"/>
+                </a:solidFill>
+                <a:latin typeface="Arial"/>
+              </a:rPr>
+              <a:t>C. Both groups</a:t>
+            </a:r>
+          </a:p>
+          <a:p>
+            <a:pPr algn="l" marL="228600" indent="-228600">
+              <a:spcAft>
+                <a:spcPts val="700"/>
+              </a:spcAft>
+              <a:buChar char="•"/>
+            </a:pPr>
+            <a:r>
+              <a:rPr sz="1600" b="0">
+                <a:solidFill>
+                  <a:srgbClr val="262B30"/>
+                </a:solidFill>
+                <a:latin typeface="Arial"/>
+              </a:rPr>
+              <a:t>Overall, I was satisfied with today's sightseeing</a:t>
+            </a:r>
+          </a:p>
+          <a:p>
+            <a:pPr algn="l" marL="228600" indent="-228600">
+              <a:spcAft>
+                <a:spcPts val="700"/>
+              </a:spcAft>
+              <a:buChar char="•"/>
+            </a:pPr>
+            <a:r>
+              <a:rPr sz="1600" b="0">
+                <a:solidFill>
+                  <a:srgbClr val="262B30"/>
+                </a:solidFill>
+                <a:latin typeface="Arial"/>
+              </a:rPr>
+              <a:t>I enjoyed walking around Asakusa today</a:t>
+            </a:r>
+          </a:p>
+          <a:p>
+            <a:pPr algn="l" marL="228600" indent="-228600">
+              <a:spcAft>
+                <a:spcPts val="700"/>
+              </a:spcAft>
+              <a:buChar char="•"/>
+            </a:pPr>
+            <a:r>
+              <a:rPr sz="1600" b="0">
+                <a:solidFill>
+                  <a:srgbClr val="262B30"/>
+                </a:solidFill>
+                <a:latin typeface="Arial"/>
+              </a:rPr>
+              <a:t>I visited places I would not have visited otherwise</a:t>
+            </a:r>
+          </a:p>
+          <a:p>
+            <a:pPr algn="l" marL="228600" indent="-228600">
+              <a:spcAft>
+                <a:spcPts val="700"/>
+              </a:spcAft>
+              <a:buChar char="•"/>
+            </a:pPr>
+            <a:r>
+              <a:rPr sz="1600" b="0">
+                <a:solidFill>
+                  <a:srgbClr val="262B30"/>
+                </a:solidFill>
+                <a:latin typeface="Arial"/>
+              </a:rPr>
+              <a:t>The places I visited felt crowded</a:t>
+            </a:r>
+          </a:p>
+          <a:p>
+            <a:pPr algn="l" marL="228600" indent="-228600">
+              <a:spcAft>
+                <a:spcPts val="700"/>
+              </a:spcAft>
+              <a:buChar char="•"/>
+            </a:pPr>
+            <a:r>
+              <a:rPr sz="1600" b="0">
+                <a:solidFill>
+                  <a:srgbClr val="262B30"/>
+                </a:solidFill>
+                <a:latin typeface="Arial"/>
+              </a:rPr>
+              <a:t>I would like to visit Asakusa again</a:t>
+            </a:r>
+          </a:p>
+          <a:p>
+            <a:pPr algn="l" marL="228600" indent="-228600">
+              <a:spcAft>
+                <a:spcPts val="700"/>
+              </a:spcAft>
+              <a:buChar char="•"/>
+            </a:pPr>
+            <a:r>
+              <a:rPr sz="1600" b="0">
+                <a:solidFill>
+                  <a:srgbClr val="262B30"/>
+                </a:solidFill>
+                <a:latin typeface="Arial"/>
+              </a:rPr>
+              <a:t>I would recommend the less-known places I visited</a:t>
+            </a:r>
+          </a:p>
+          <a:p>
+            <a:pPr algn="l" marL="228600" indent="-228600">
+              <a:spcAft>
+                <a:spcPts val="700"/>
+              </a:spcAft>
+              <a:buChar char="•"/>
+            </a:pPr>
+            <a:r>
+              <a:rPr sz="1600" b="0">
+                <a:solidFill>
+                  <a:srgbClr val="262B30"/>
+                </a:solidFill>
+                <a:latin typeface="Arial"/>
+              </a:rPr>
+              <a:t>The app was easy to use</a:t>
+            </a:r>
+          </a:p>
+          <a:p>
+            <a:pPr algn="l" marL="228600" indent="-228600">
+              <a:spcAft>
+                <a:spcPts val="700"/>
+              </a:spcAft>
+              <a:buChar char="•"/>
+            </a:pPr>
+            <a:r>
+              <a:rPr sz="1600" b="0">
+                <a:solidFill>
+                  <a:srgbClr val="262B30"/>
+                </a:solidFill>
+                <a:latin typeface="Arial"/>
+              </a:rPr>
+              <a:t>Which of the 16 checkpoints did you visit? (checklist)</a:t>
+            </a:r>
+          </a:p>
+          <a:p>
+            <a:pPr algn="l" marL="228600" indent="-228600">
+              <a:spcAft>
+                <a:spcPts val="700"/>
+              </a:spcAft>
+              <a:buChar char="•"/>
+            </a:pPr>
+            <a:r>
+              <a:rPr sz="1600" b="0">
+                <a:solidFill>
+                  <a:srgbClr val="262B30"/>
+                </a:solidFill>
+                <a:latin typeface="Arial"/>
+              </a:rPr>
+              <a:t>Why did you choose those places? (map information / on my way / looked interesting / game / other)</a:t>
+            </a:r>
+          </a:p>
+          <a:p>
+            <a:pPr algn="l" marL="228600" indent="-228600">
+              <a:spcAft>
+                <a:spcPts val="700"/>
+              </a:spcAft>
+              <a:buChar char="•"/>
+            </a:pPr>
+            <a:r>
+              <a:rPr sz="1600" b="0">
+                <a:solidFill>
+                  <a:srgbClr val="262B30"/>
+                </a:solidFill>
+                <a:latin typeface="Arial"/>
+              </a:rPr>
+              <a:t>Free comment</a:t>
+            </a:r>
+          </a:p>
+        </p:txBody>
+      </p:sp>
+      <p:sp>
+        <p:nvSpPr>
+          <p:cNvPr id="56" name="Questionnaire right"/>
+          <p:cNvSpPr/>
+          <p:nvPr/>
+        </p:nvSpPr>
+        <p:spPr>
+          <a:xfrm>
+            <a:off x="6900000" y="1930000"/>
+            <a:ext cx="5650000" cy="4900000"/>
+          </a:xfrm>
+          <a:prstGeom prst="roundRect">
+            <a:avLst>
+              <a:gd name="adj" fmla="val 6000"/>
+            </a:avLst>
+          </a:prstGeom>
+          <a:solidFill>
+            <a:srgbClr val="E9F6F9"/>
+          </a:solidFill>
+          <a:ln>
+            <a:noFill/>
+          </a:ln>
+          <a:effectLst/>
+        </p:spPr>
+        <p:style>
+          <a:lnRef idx="1">
+            <a:schemeClr val="accent1"/>
+          </a:lnRef>
+          <a:fillRef idx="3">
+            <a:schemeClr val="accent1"/>
+          </a:fillRef>
+          <a:effectRef idx="2">
+            <a:schemeClr val="accent1"/>
+          </a:effectRef>
+          <a:fontRef idx="minor">
+            <a:schemeClr val="lt1"/>
+          </a:fontRef>
+        </p:style>
+        <p:txBody>
+          <a:bodyPr rtlCol="0" anchor="ctr"/>
+          <a:lstStyle/>
+          <a:p/>
+        </p:txBody>
+      </p:sp>
+      <p:sp>
+        <p:nvSpPr>
+          <p:cNvPr id="57" name="TextBox 56"/>
+          <p:cNvSpPr txBox="1"/>
+          <p:nvPr/>
+        </p:nvSpPr>
+        <p:spPr>
+          <a:xfrm>
+            <a:off x="7160000" y="2100000"/>
+            <a:ext cx="5130000" cy="4600000"/>
+          </a:xfrm>
+          <a:prstGeom prst="rect">
+            <a:avLst/>
+          </a:prstGeom>
+          <a:noFill/>
+        </p:spPr>
+        <p:txBody>
+          <a:bodyPr wrap="square" anchor="t" lIns="0" rIns="0" tIns="0" bIns="0">
+            <a:spAutoFit/>
+          </a:bodyPr>
+          <a:lstStyle/>
+          <a:p>
+            <a:pPr algn="l">
+              <a:spcAft>
+                <a:spcPts val="800"/>
+              </a:spcAft>
+            </a:pPr>
+            <a:r>
+              <a:rPr sz="1800" b="1">
+                <a:solidFill>
+                  <a:srgbClr val="0F2F46"/>
+                </a:solidFill>
+                <a:latin typeface="Arial"/>
+              </a:rPr>
+              <a:t>D. Gamification group only</a:t>
+            </a:r>
+          </a:p>
+          <a:p>
+            <a:pPr algn="l" marL="228600" indent="-228600">
+              <a:spcAft>
+                <a:spcPts val="700"/>
+              </a:spcAft>
+              <a:buChar char="•"/>
+            </a:pPr>
+            <a:r>
+              <a:rPr sz="1600" b="0">
+                <a:solidFill>
+                  <a:srgbClr val="262B30"/>
+                </a:solidFill>
+                <a:latin typeface="Arial"/>
+              </a:rPr>
+              <a:t>Priority, 1–5: "I focused on sightseeing" ↔ "I focused on the game" (Kawanaka et al.)</a:t>
+            </a:r>
+          </a:p>
+          <a:p>
+            <a:pPr algn="l" marL="228600" indent="-228600">
+              <a:spcAft>
+                <a:spcPts val="700"/>
+              </a:spcAft>
+              <a:buChar char="•"/>
+            </a:pPr>
+            <a:r>
+              <a:rPr sz="1600" b="0">
+                <a:solidFill>
+                  <a:srgbClr val="262B30"/>
+                </a:solidFill>
+                <a:latin typeface="Arial"/>
+              </a:rPr>
+              <a:t>Each feature affected where I went: points / photo missions / stamp rally / ranking / medals (1–5 each)</a:t>
+            </a:r>
+          </a:p>
+          <a:p>
+            <a:pPr algn="l" marL="228600" indent="-228600">
+              <a:spcAft>
+                <a:spcPts val="700"/>
+              </a:spcAft>
+              <a:buChar char="•"/>
+            </a:pPr>
+            <a:r>
+              <a:rPr sz="1600" b="0">
+                <a:solidFill>
+                  <a:srgbClr val="262B30"/>
+                </a:solidFill>
+                <a:latin typeface="Arial"/>
+              </a:rPr>
+              <a:t>The game made the trip more enjoyable</a:t>
+            </a:r>
+          </a:p>
+          <a:p>
+            <a:pPr algn="l" marL="228600" indent="-228600">
+              <a:spcAft>
+                <a:spcPts val="700"/>
+              </a:spcAft>
+              <a:buChar char="•"/>
+            </a:pPr>
+            <a:r>
+              <a:rPr sz="1600" b="0">
+                <a:solidFill>
+                  <a:srgbClr val="262B30"/>
+                </a:solidFill>
+                <a:latin typeface="Arial"/>
+              </a:rPr>
+              <a:t>The game made me feel rushed</a:t>
+            </a:r>
+          </a:p>
+          <a:p>
+            <a:pPr algn="l" marL="228600" indent="-228600">
+              <a:spcAft>
+                <a:spcPts val="700"/>
+              </a:spcAft>
+              <a:buChar char="•"/>
+            </a:pPr>
+            <a:r>
+              <a:rPr sz="1600" b="0">
+                <a:solidFill>
+                  <a:srgbClr val="262B30"/>
+                </a:solidFill>
+                <a:latin typeface="Arial"/>
+              </a:rPr>
+              <a:t>I would use these game features on a future trip</a:t>
+            </a:r>
+          </a:p>
+        </p:txBody>
+      </p:sp>
+    </p:spTree>
+  </p:cSld>
+  <p:clrMapOvr>
+    <a:masterClrMapping/>
+  </p:clrMapOvr>
+</p:sld>
+</file>
+
+<file path=ppt/slides/slide21.xml><?xml version="1.0" encoding="utf-8"?>
 <p:sld xmlns:a="http://schemas.openxmlformats.org/drawingml/2006/main" xmlns:r="http://schemas.openxmlformats.org/officeDocument/2006/relationships" xmlns:mc="http://schemas.openxmlformats.org/markup-compatibility/2006" xmlns:mv="urn:schemas-microsoft-com:mac:vml" xmlns:p="http://schemas.openxmlformats.org/presentationml/2006/main" xmlns:c="http://schemas.openxmlformats.org/drawingml/2006/chart" xmlns:dgm="http://schemas.openxmlformats.org/drawingml/2006/diagram" xmlns:o="urn:schemas-microsoft-com:office:office" xmlns:v="urn:schemas-microsoft-com:vml" xmlns:pvml="urn:schemas-microsoft-com:office:powerpoint" xmlns:com="http://schemas.openxmlformats.org/drawingml/2006/compatibility" xmlns:p14="http://schemas.microsoft.com/office/powerpoint/2010/main" xmlns:p15="http://schemas.microsoft.com/office/powerpoint/2012/main" xmlns:ahyp="http://schemas.microsoft.com/office/drawing/2018/hyperlinkcolor">
   <p:cSld>
     <p:spTree>
@@ -16819,1213 +19287,7 @@
 </p:sld>
 </file>
 
-<file path=ppt/slides/slide2.xml><?xml version="1.0" encoding="utf-8"?>
-<p:sld xmlns:a="http://schemas.openxmlformats.org/drawingml/2006/main" xmlns:r="http://schemas.openxmlformats.org/officeDocument/2006/relationships" xmlns:mc="http://schemas.openxmlformats.org/markup-compatibility/2006" xmlns:mv="urn:schemas-microsoft-com:mac:vml" xmlns:p="http://schemas.openxmlformats.org/presentationml/2006/main" xmlns:c="http://schemas.openxmlformats.org/drawingml/2006/chart" xmlns:dgm="http://schemas.openxmlformats.org/drawingml/2006/diagram" xmlns:o="urn:schemas-microsoft-com:office:office" xmlns:v="urn:schemas-microsoft-com:vml" xmlns:pvml="urn:schemas-microsoft-com:office:powerpoint" xmlns:com="http://schemas.openxmlformats.org/drawingml/2006/compatibility" xmlns:p14="http://schemas.microsoft.com/office/powerpoint/2010/main" xmlns:p15="http://schemas.microsoft.com/office/powerpoint/2012/main" xmlns:ahyp="http://schemas.microsoft.com/office/drawing/2018/hyperlinkcolor">
-  <p:cSld>
-    <p:spTree>
-      <p:nvGrpSpPr>
-        <p:cNvPr id="50" name="Shape 50"/>
-        <p:cNvGrpSpPr/>
-        <p:nvPr/>
-      </p:nvGrpSpPr>
-      <p:grpSpPr>
-        <a:xfrm>
-          <a:off x="0" y="0"/>
-          <a:ext cx="0" cy="0"/>
-          <a:chOff x="0" y="0"/>
-          <a:chExt cx="0" cy="0"/>
-        </a:xfrm>
-      </p:grpSpPr>
-      <p:sp>
-        <p:nvSpPr>
-          <p:cNvPr id="51" name="Google Shape;51;p8"/>
-          <p:cNvSpPr txBox="1"/>
-          <p:nvPr>
-            <p:ph idx="12" type="sldNum"/>
-          </p:nvPr>
-        </p:nvSpPr>
-        <p:spPr>
-          <a:xfrm>
-            <a:off x="9074817" y="7033452"/>
-            <a:ext cx="2459482" cy="276999"/>
-          </a:xfrm>
-          <a:prstGeom prst="rect">
-            <a:avLst/>
-          </a:prstGeom>
-          <a:noFill/>
-          <a:ln>
-            <a:noFill/>
-          </a:ln>
-        </p:spPr>
-        <p:txBody>
-          <a:bodyPr anchorCtr="0" anchor="t" bIns="0" lIns="0" spcFirstLastPara="1" rIns="0" wrap="square" tIns="0">
-            <a:noAutofit/>
-          </a:bodyPr>
-          <a:lstStyle/>
-          <a:p>
-            <a:pPr indent="0" lvl="0" marL="0" rtl="0" algn="r">
-              <a:lnSpc>
-                <a:spcPct val="100000"/>
-              </a:lnSpc>
-              <a:spcBef>
-                <a:spcPts val="0"/>
-              </a:spcBef>
-              <a:spcAft>
-                <a:spcPts val="0"/>
-              </a:spcAft>
-              <a:buSzPts val="1800"/>
-              <a:buNone/>
-            </a:pPr>
-            <a:fld id="{00000000-1234-1234-1234-123412341234}" type="slidenum">
-              <a:rPr lang="en-US"/>
-              <a:t>‹#›</a:t>
-            </a:fld>
-            <a:endParaRPr/>
-          </a:p>
-        </p:txBody>
-      </p:sp>
-      <p:sp>
-        <p:nvSpPr>
-          <p:cNvPr id="52" name="Google Shape;52;p8"/>
-          <p:cNvSpPr txBox="1"/>
-          <p:nvPr/>
-        </p:nvSpPr>
-        <p:spPr>
-          <a:xfrm>
-            <a:off x="898635" y="409903"/>
-            <a:ext cx="9800000" cy="584775"/>
-          </a:xfrm>
-          <a:prstGeom prst="rect">
-            <a:avLst/>
-          </a:prstGeom>
-          <a:noFill/>
-          <a:ln>
-            <a:noFill/>
-          </a:ln>
-        </p:spPr>
-        <p:txBody>
-          <a:bodyPr anchorCtr="0" anchor="t" bIns="45700" lIns="91425" spcFirstLastPara="1" rIns="91425" wrap="square" tIns="45700">
-            <a:spAutoFit/>
-          </a:bodyPr>
-          <a:lstStyle/>
-          <a:p>
-            <a:pPr indent="0" lvl="0" marL="0" marR="0" rtl="0" algn="l">
-              <a:lnSpc>
-                <a:spcPct val="100000"/>
-              </a:lnSpc>
-              <a:spcBef>
-                <a:spcPts val="0"/>
-              </a:spcBef>
-              <a:spcAft>
-                <a:spcPts val="0"/>
-              </a:spcAft>
-              <a:buNone/>
-            </a:pPr>
-            <a:r>
-              <a:rPr b="1" i="0" lang="en-US" sz="3200" u="none" cap="none" strike="noStrike">
-                <a:solidFill>
-                  <a:srgbClr val="000000"/>
-                </a:solidFill>
-                <a:latin typeface="Arial"/>
-                <a:ea typeface="Arial"/>
-                <a:cs typeface="Arial"/>
-                <a:sym typeface="Arial"/>
-              </a:rPr>
-              <a:t>Table of contents</a:t>
-            </a:r>
-            <a:endParaRPr/>
-          </a:p>
-        </p:txBody>
-      </p:sp>
-      <p:sp>
-        <p:nvSpPr>
-          <p:cNvPr id="53" name="TOC number 1"/>
-          <p:cNvSpPr/>
-          <p:nvPr/>
-        </p:nvSpPr>
-        <p:spPr>
-          <a:xfrm>
-            <a:off x="900000" y="1440000"/>
-            <a:ext cx="520000" cy="520000"/>
-          </a:xfrm>
-          <a:prstGeom prst="ellipse">
-            <a:avLst/>
-          </a:prstGeom>
-          <a:solidFill>
-            <a:srgbClr val="7BCFDF"/>
-          </a:solidFill>
-          <a:ln>
-            <a:noFill/>
-          </a:ln>
-          <a:effectLst/>
-        </p:spPr>
-        <p:style>
-          <a:lnRef idx="1">
-            <a:schemeClr val="accent1"/>
-          </a:lnRef>
-          <a:fillRef idx="3">
-            <a:schemeClr val="accent1"/>
-          </a:fillRef>
-          <a:effectRef idx="2">
-            <a:schemeClr val="accent1"/>
-          </a:effectRef>
-          <a:fontRef idx="minor">
-            <a:schemeClr val="lt1"/>
-          </a:fontRef>
-        </p:style>
-        <p:txBody>
-          <a:bodyPr rtlCol="0" anchor="ctr"/>
-          <a:lstStyle/>
-          <a:p/>
-        </p:txBody>
-      </p:sp>
-      <p:sp>
-        <p:nvSpPr>
-          <p:cNvPr id="54" name="TextBox 53"/>
-          <p:cNvSpPr txBox="1"/>
-          <p:nvPr/>
-        </p:nvSpPr>
-        <p:spPr>
-          <a:xfrm>
-            <a:off x="900000" y="1440000"/>
-            <a:ext cx="520000" cy="520000"/>
-          </a:xfrm>
-          <a:prstGeom prst="rect">
-            <a:avLst/>
-          </a:prstGeom>
-          <a:noFill/>
-        </p:spPr>
-        <p:txBody>
-          <a:bodyPr wrap="square" anchor="ctr" lIns="0" rIns="0" tIns="0" bIns="0">
-            <a:spAutoFit/>
-          </a:bodyPr>
-          <a:lstStyle/>
-          <a:p>
-            <a:pPr algn="ctr">
-              <a:spcAft>
-                <a:spcPts val="0"/>
-              </a:spcAft>
-            </a:pPr>
-            <a:r>
-              <a:rPr sz="1800" b="1">
-                <a:solidFill>
-                  <a:srgbClr val="0F2F46"/>
-                </a:solidFill>
-                <a:latin typeface="Arial"/>
-              </a:rPr>
-              <a:t>1</a:t>
-            </a:r>
-          </a:p>
-        </p:txBody>
-      </p:sp>
-      <p:sp>
-        <p:nvSpPr>
-          <p:cNvPr id="55" name="TextBox 54"/>
-          <p:cNvSpPr txBox="1"/>
-          <p:nvPr/>
-        </p:nvSpPr>
-        <p:spPr>
-          <a:xfrm>
-            <a:off x="1650000" y="1440000"/>
-            <a:ext cx="9000000" cy="520000"/>
-          </a:xfrm>
-          <a:prstGeom prst="rect">
-            <a:avLst/>
-          </a:prstGeom>
-          <a:noFill/>
-        </p:spPr>
-        <p:txBody>
-          <a:bodyPr wrap="square" anchor="ctr" lIns="0" rIns="0" tIns="0" bIns="0">
-            <a:spAutoFit/>
-          </a:bodyPr>
-          <a:lstStyle/>
-          <a:p>
-            <a:pPr algn="l">
-              <a:spcAft>
-                <a:spcPts val="0"/>
-              </a:spcAft>
-            </a:pPr>
-            <a:r>
-              <a:rPr sz="2000" b="0">
-                <a:solidFill>
-                  <a:srgbClr val="262B30"/>
-                </a:solidFill>
-                <a:latin typeface="Arial"/>
-              </a:rPr>
-              <a:t>Experiment at a glance</a:t>
-            </a:r>
-          </a:p>
-        </p:txBody>
-      </p:sp>
-      <p:sp>
-        <p:nvSpPr>
-          <p:cNvPr id="56" name="TOC number 2"/>
-          <p:cNvSpPr/>
-          <p:nvPr/>
-        </p:nvSpPr>
-        <p:spPr>
-          <a:xfrm>
-            <a:off x="900000" y="2040000"/>
-            <a:ext cx="520000" cy="520000"/>
-          </a:xfrm>
-          <a:prstGeom prst="ellipse">
-            <a:avLst/>
-          </a:prstGeom>
-          <a:solidFill>
-            <a:srgbClr val="0F2F46"/>
-          </a:solidFill>
-          <a:ln>
-            <a:noFill/>
-          </a:ln>
-          <a:effectLst/>
-        </p:spPr>
-        <p:style>
-          <a:lnRef idx="1">
-            <a:schemeClr val="accent1"/>
-          </a:lnRef>
-          <a:fillRef idx="3">
-            <a:schemeClr val="accent1"/>
-          </a:fillRef>
-          <a:effectRef idx="2">
-            <a:schemeClr val="accent1"/>
-          </a:effectRef>
-          <a:fontRef idx="minor">
-            <a:schemeClr val="lt1"/>
-          </a:fontRef>
-        </p:style>
-        <p:txBody>
-          <a:bodyPr rtlCol="0" anchor="ctr"/>
-          <a:lstStyle/>
-          <a:p/>
-        </p:txBody>
-      </p:sp>
-      <p:sp>
-        <p:nvSpPr>
-          <p:cNvPr id="57" name="TextBox 56"/>
-          <p:cNvSpPr txBox="1"/>
-          <p:nvPr/>
-        </p:nvSpPr>
-        <p:spPr>
-          <a:xfrm>
-            <a:off x="900000" y="2040000"/>
-            <a:ext cx="520000" cy="520000"/>
-          </a:xfrm>
-          <a:prstGeom prst="rect">
-            <a:avLst/>
-          </a:prstGeom>
-          <a:noFill/>
-        </p:spPr>
-        <p:txBody>
-          <a:bodyPr wrap="square" anchor="ctr" lIns="0" rIns="0" tIns="0" bIns="0">
-            <a:spAutoFit/>
-          </a:bodyPr>
-          <a:lstStyle/>
-          <a:p>
-            <a:pPr algn="ctr">
-              <a:spcAft>
-                <a:spcPts val="0"/>
-              </a:spcAft>
-            </a:pPr>
-            <a:r>
-              <a:rPr sz="1800" b="1">
-                <a:solidFill>
-                  <a:srgbClr val="FFFFFF"/>
-                </a:solidFill>
-                <a:latin typeface="Arial"/>
-              </a:rPr>
-              <a:t>2</a:t>
-            </a:r>
-          </a:p>
-        </p:txBody>
-      </p:sp>
-      <p:sp>
-        <p:nvSpPr>
-          <p:cNvPr id="58" name="TextBox 57"/>
-          <p:cNvSpPr txBox="1"/>
-          <p:nvPr/>
-        </p:nvSpPr>
-        <p:spPr>
-          <a:xfrm>
-            <a:off x="1650000" y="2040000"/>
-            <a:ext cx="9000000" cy="520000"/>
-          </a:xfrm>
-          <a:prstGeom prst="rect">
-            <a:avLst/>
-          </a:prstGeom>
-          <a:noFill/>
-        </p:spPr>
-        <p:txBody>
-          <a:bodyPr wrap="square" anchor="ctr" lIns="0" rIns="0" tIns="0" bIns="0">
-            <a:spAutoFit/>
-          </a:bodyPr>
-          <a:lstStyle/>
-          <a:p>
-            <a:pPr algn="l">
-              <a:spcAft>
-                <a:spcPts val="0"/>
-              </a:spcAft>
-            </a:pPr>
-            <a:r>
-              <a:rPr sz="2000" b="0">
-                <a:solidFill>
-                  <a:srgbClr val="262B30"/>
-                </a:solidFill>
-                <a:latin typeface="Arial"/>
-              </a:rPr>
-              <a:t>Checkpoint list (16 spots)</a:t>
-            </a:r>
-          </a:p>
-        </p:txBody>
-      </p:sp>
-      <p:sp>
-        <p:nvSpPr>
-          <p:cNvPr id="59" name="TOC number 3"/>
-          <p:cNvSpPr/>
-          <p:nvPr/>
-        </p:nvSpPr>
-        <p:spPr>
-          <a:xfrm>
-            <a:off x="900000" y="2640000"/>
-            <a:ext cx="520000" cy="520000"/>
-          </a:xfrm>
-          <a:prstGeom prst="ellipse">
-            <a:avLst/>
-          </a:prstGeom>
-          <a:solidFill>
-            <a:srgbClr val="7BCFDF"/>
-          </a:solidFill>
-          <a:ln>
-            <a:noFill/>
-          </a:ln>
-          <a:effectLst/>
-        </p:spPr>
-        <p:style>
-          <a:lnRef idx="1">
-            <a:schemeClr val="accent1"/>
-          </a:lnRef>
-          <a:fillRef idx="3">
-            <a:schemeClr val="accent1"/>
-          </a:fillRef>
-          <a:effectRef idx="2">
-            <a:schemeClr val="accent1"/>
-          </a:effectRef>
-          <a:fontRef idx="minor">
-            <a:schemeClr val="lt1"/>
-          </a:fontRef>
-        </p:style>
-        <p:txBody>
-          <a:bodyPr rtlCol="0" anchor="ctr"/>
-          <a:lstStyle/>
-          <a:p/>
-        </p:txBody>
-      </p:sp>
-      <p:sp>
-        <p:nvSpPr>
-          <p:cNvPr id="60" name="TextBox 59"/>
-          <p:cNvSpPr txBox="1"/>
-          <p:nvPr/>
-        </p:nvSpPr>
-        <p:spPr>
-          <a:xfrm>
-            <a:off x="900000" y="2640000"/>
-            <a:ext cx="520000" cy="520000"/>
-          </a:xfrm>
-          <a:prstGeom prst="rect">
-            <a:avLst/>
-          </a:prstGeom>
-          <a:noFill/>
-        </p:spPr>
-        <p:txBody>
-          <a:bodyPr wrap="square" anchor="ctr" lIns="0" rIns="0" tIns="0" bIns="0">
-            <a:spAutoFit/>
-          </a:bodyPr>
-          <a:lstStyle/>
-          <a:p>
-            <a:pPr algn="ctr">
-              <a:spcAft>
-                <a:spcPts val="0"/>
-              </a:spcAft>
-            </a:pPr>
-            <a:r>
-              <a:rPr sz="1800" b="1">
-                <a:solidFill>
-                  <a:srgbClr val="0F2F46"/>
-                </a:solidFill>
-                <a:latin typeface="Arial"/>
-              </a:rPr>
-              <a:t>3</a:t>
-            </a:r>
-          </a:p>
-        </p:txBody>
-      </p:sp>
-      <p:sp>
-        <p:nvSpPr>
-          <p:cNvPr id="61" name="TextBox 60"/>
-          <p:cNvSpPr txBox="1"/>
-          <p:nvPr/>
-        </p:nvSpPr>
-        <p:spPr>
-          <a:xfrm>
-            <a:off x="1650000" y="2640000"/>
-            <a:ext cx="9000000" cy="520000"/>
-          </a:xfrm>
-          <a:prstGeom prst="rect">
-            <a:avLst/>
-          </a:prstGeom>
-          <a:noFill/>
-        </p:spPr>
-        <p:txBody>
-          <a:bodyPr wrap="square" anchor="ctr" lIns="0" rIns="0" tIns="0" bIns="0">
-            <a:spAutoFit/>
-          </a:bodyPr>
-          <a:lstStyle/>
-          <a:p>
-            <a:pPr algn="l">
-              <a:spcAft>
-                <a:spcPts val="0"/>
-              </a:spcAft>
-            </a:pPr>
-            <a:r>
-              <a:rPr sz="2000" b="0">
-                <a:solidFill>
-                  <a:srgbClr val="262B30"/>
-                </a:solidFill>
-                <a:latin typeface="Arial"/>
-              </a:rPr>
-              <a:t>Spot details</a:t>
-            </a:r>
-          </a:p>
-        </p:txBody>
-      </p:sp>
-      <p:sp>
-        <p:nvSpPr>
-          <p:cNvPr id="62" name="TOC number 4"/>
-          <p:cNvSpPr/>
-          <p:nvPr/>
-        </p:nvSpPr>
-        <p:spPr>
-          <a:xfrm>
-            <a:off x="900000" y="3240000"/>
-            <a:ext cx="520000" cy="520000"/>
-          </a:xfrm>
-          <a:prstGeom prst="ellipse">
-            <a:avLst/>
-          </a:prstGeom>
-          <a:solidFill>
-            <a:srgbClr val="0F2F46"/>
-          </a:solidFill>
-          <a:ln>
-            <a:noFill/>
-          </a:ln>
-          <a:effectLst/>
-        </p:spPr>
-        <p:style>
-          <a:lnRef idx="1">
-            <a:schemeClr val="accent1"/>
-          </a:lnRef>
-          <a:fillRef idx="3">
-            <a:schemeClr val="accent1"/>
-          </a:fillRef>
-          <a:effectRef idx="2">
-            <a:schemeClr val="accent1"/>
-          </a:effectRef>
-          <a:fontRef idx="minor">
-            <a:schemeClr val="lt1"/>
-          </a:fontRef>
-        </p:style>
-        <p:txBody>
-          <a:bodyPr rtlCol="0" anchor="ctr"/>
-          <a:lstStyle/>
-          <a:p/>
-        </p:txBody>
-      </p:sp>
-      <p:sp>
-        <p:nvSpPr>
-          <p:cNvPr id="63" name="TextBox 62"/>
-          <p:cNvSpPr txBox="1"/>
-          <p:nvPr/>
-        </p:nvSpPr>
-        <p:spPr>
-          <a:xfrm>
-            <a:off x="900000" y="3240000"/>
-            <a:ext cx="520000" cy="520000"/>
-          </a:xfrm>
-          <a:prstGeom prst="rect">
-            <a:avLst/>
-          </a:prstGeom>
-          <a:noFill/>
-        </p:spPr>
-        <p:txBody>
-          <a:bodyPr wrap="square" anchor="ctr" lIns="0" rIns="0" tIns="0" bIns="0">
-            <a:spAutoFit/>
-          </a:bodyPr>
-          <a:lstStyle/>
-          <a:p>
-            <a:pPr algn="ctr">
-              <a:spcAft>
-                <a:spcPts val="0"/>
-              </a:spcAft>
-            </a:pPr>
-            <a:r>
-              <a:rPr sz="1800" b="1">
-                <a:solidFill>
-                  <a:srgbClr val="FFFFFF"/>
-                </a:solidFill>
-                <a:latin typeface="Arial"/>
-              </a:rPr>
-              <a:t>4</a:t>
-            </a:r>
-          </a:p>
-        </p:txBody>
-      </p:sp>
-      <p:sp>
-        <p:nvSpPr>
-          <p:cNvPr id="64" name="TextBox 63"/>
-          <p:cNvSpPr txBox="1"/>
-          <p:nvPr/>
-        </p:nvSpPr>
-        <p:spPr>
-          <a:xfrm>
-            <a:off x="1650000" y="3240000"/>
-            <a:ext cx="9000000" cy="520000"/>
-          </a:xfrm>
-          <a:prstGeom prst="rect">
-            <a:avLst/>
-          </a:prstGeom>
-          <a:noFill/>
-        </p:spPr>
-        <p:txBody>
-          <a:bodyPr wrap="square" anchor="ctr" lIns="0" rIns="0" tIns="0" bIns="0">
-            <a:spAutoFit/>
-          </a:bodyPr>
-          <a:lstStyle/>
-          <a:p>
-            <a:pPr algn="l">
-              <a:spcAft>
-                <a:spcPts val="0"/>
-              </a:spcAft>
-            </a:pPr>
-            <a:r>
-              <a:rPr sz="2000" b="0">
-                <a:solidFill>
-                  <a:srgbClr val="262B30"/>
-                </a:solidFill>
-                <a:latin typeface="Arial"/>
-              </a:rPr>
-              <a:t>Points and stamp rally</a:t>
-            </a:r>
-          </a:p>
-        </p:txBody>
-      </p:sp>
-      <p:sp>
-        <p:nvSpPr>
-          <p:cNvPr id="65" name="TOC number 5"/>
-          <p:cNvSpPr/>
-          <p:nvPr/>
-        </p:nvSpPr>
-        <p:spPr>
-          <a:xfrm>
-            <a:off x="900000" y="3840000"/>
-            <a:ext cx="520000" cy="520000"/>
-          </a:xfrm>
-          <a:prstGeom prst="ellipse">
-            <a:avLst/>
-          </a:prstGeom>
-          <a:solidFill>
-            <a:srgbClr val="7BCFDF"/>
-          </a:solidFill>
-          <a:ln>
-            <a:noFill/>
-          </a:ln>
-          <a:effectLst/>
-        </p:spPr>
-        <p:style>
-          <a:lnRef idx="1">
-            <a:schemeClr val="accent1"/>
-          </a:lnRef>
-          <a:fillRef idx="3">
-            <a:schemeClr val="accent1"/>
-          </a:fillRef>
-          <a:effectRef idx="2">
-            <a:schemeClr val="accent1"/>
-          </a:effectRef>
-          <a:fontRef idx="minor">
-            <a:schemeClr val="lt1"/>
-          </a:fontRef>
-        </p:style>
-        <p:txBody>
-          <a:bodyPr rtlCol="0" anchor="ctr"/>
-          <a:lstStyle/>
-          <a:p/>
-        </p:txBody>
-      </p:sp>
-      <p:sp>
-        <p:nvSpPr>
-          <p:cNvPr id="66" name="TextBox 65"/>
-          <p:cNvSpPr txBox="1"/>
-          <p:nvPr/>
-        </p:nvSpPr>
-        <p:spPr>
-          <a:xfrm>
-            <a:off x="900000" y="3840000"/>
-            <a:ext cx="520000" cy="520000"/>
-          </a:xfrm>
-          <a:prstGeom prst="rect">
-            <a:avLst/>
-          </a:prstGeom>
-          <a:noFill/>
-        </p:spPr>
-        <p:txBody>
-          <a:bodyPr wrap="square" anchor="ctr" lIns="0" rIns="0" tIns="0" bIns="0">
-            <a:spAutoFit/>
-          </a:bodyPr>
-          <a:lstStyle/>
-          <a:p>
-            <a:pPr algn="ctr">
-              <a:spcAft>
-                <a:spcPts val="0"/>
-              </a:spcAft>
-            </a:pPr>
-            <a:r>
-              <a:rPr sz="1800" b="1">
-                <a:solidFill>
-                  <a:srgbClr val="0F2F46"/>
-                </a:solidFill>
-                <a:latin typeface="Arial"/>
-              </a:rPr>
-              <a:t>5</a:t>
-            </a:r>
-          </a:p>
-        </p:txBody>
-      </p:sp>
-      <p:sp>
-        <p:nvSpPr>
-          <p:cNvPr id="67" name="TextBox 66"/>
-          <p:cNvSpPr txBox="1"/>
-          <p:nvPr/>
-        </p:nvSpPr>
-        <p:spPr>
-          <a:xfrm>
-            <a:off x="1650000" y="3840000"/>
-            <a:ext cx="9000000" cy="520000"/>
-          </a:xfrm>
-          <a:prstGeom prst="rect">
-            <a:avLst/>
-          </a:prstGeom>
-          <a:noFill/>
-        </p:spPr>
-        <p:txBody>
-          <a:bodyPr wrap="square" anchor="ctr" lIns="0" rIns="0" tIns="0" bIns="0">
-            <a:spAutoFit/>
-          </a:bodyPr>
-          <a:lstStyle/>
-          <a:p>
-            <a:pPr algn="l">
-              <a:spcAft>
-                <a:spcPts val="0"/>
-              </a:spcAft>
-            </a:pPr>
-            <a:r>
-              <a:rPr sz="2000" b="0">
-                <a:solidFill>
-                  <a:srgbClr val="262B30"/>
-                </a:solidFill>
-                <a:latin typeface="Arial"/>
-              </a:rPr>
-              <a:t>Participant instructions</a:t>
-            </a:r>
-          </a:p>
-        </p:txBody>
-      </p:sp>
-      <p:sp>
-        <p:nvSpPr>
-          <p:cNvPr id="68" name="TOC number 6"/>
-          <p:cNvSpPr/>
-          <p:nvPr/>
-        </p:nvSpPr>
-        <p:spPr>
-          <a:xfrm>
-            <a:off x="900000" y="4440000"/>
-            <a:ext cx="520000" cy="520000"/>
-          </a:xfrm>
-          <a:prstGeom prst="ellipse">
-            <a:avLst/>
-          </a:prstGeom>
-          <a:solidFill>
-            <a:srgbClr val="0F2F46"/>
-          </a:solidFill>
-          <a:ln>
-            <a:noFill/>
-          </a:ln>
-          <a:effectLst/>
-        </p:spPr>
-        <p:style>
-          <a:lnRef idx="1">
-            <a:schemeClr val="accent1"/>
-          </a:lnRef>
-          <a:fillRef idx="3">
-            <a:schemeClr val="accent1"/>
-          </a:fillRef>
-          <a:effectRef idx="2">
-            <a:schemeClr val="accent1"/>
-          </a:effectRef>
-          <a:fontRef idx="minor">
-            <a:schemeClr val="lt1"/>
-          </a:fontRef>
-        </p:style>
-        <p:txBody>
-          <a:bodyPr rtlCol="0" anchor="ctr"/>
-          <a:lstStyle/>
-          <a:p/>
-        </p:txBody>
-      </p:sp>
-      <p:sp>
-        <p:nvSpPr>
-          <p:cNvPr id="69" name="TextBox 68"/>
-          <p:cNvSpPr txBox="1"/>
-          <p:nvPr/>
-        </p:nvSpPr>
-        <p:spPr>
-          <a:xfrm>
-            <a:off x="900000" y="4440000"/>
-            <a:ext cx="520000" cy="520000"/>
-          </a:xfrm>
-          <a:prstGeom prst="rect">
-            <a:avLst/>
-          </a:prstGeom>
-          <a:noFill/>
-        </p:spPr>
-        <p:txBody>
-          <a:bodyPr wrap="square" anchor="ctr" lIns="0" rIns="0" tIns="0" bIns="0">
-            <a:spAutoFit/>
-          </a:bodyPr>
-          <a:lstStyle/>
-          <a:p>
-            <a:pPr algn="ctr">
-              <a:spcAft>
-                <a:spcPts val="0"/>
-              </a:spcAft>
-            </a:pPr>
-            <a:r>
-              <a:rPr sz="1800" b="1">
-                <a:solidFill>
-                  <a:srgbClr val="FFFFFF"/>
-                </a:solidFill>
-                <a:latin typeface="Arial"/>
-              </a:rPr>
-              <a:t>6</a:t>
-            </a:r>
-          </a:p>
-        </p:txBody>
-      </p:sp>
-      <p:sp>
-        <p:nvSpPr>
-          <p:cNvPr id="70" name="TextBox 69"/>
-          <p:cNvSpPr txBox="1"/>
-          <p:nvPr/>
-        </p:nvSpPr>
-        <p:spPr>
-          <a:xfrm>
-            <a:off x="1650000" y="4440000"/>
-            <a:ext cx="9000000" cy="520000"/>
-          </a:xfrm>
-          <a:prstGeom prst="rect">
-            <a:avLst/>
-          </a:prstGeom>
-          <a:noFill/>
-        </p:spPr>
-        <p:txBody>
-          <a:bodyPr wrap="square" anchor="ctr" lIns="0" rIns="0" tIns="0" bIns="0">
-            <a:spAutoFit/>
-          </a:bodyPr>
-          <a:lstStyle/>
-          <a:p>
-            <a:pPr algn="l">
-              <a:spcAft>
-                <a:spcPts val="0"/>
-              </a:spcAft>
-            </a:pPr>
-            <a:r>
-              <a:rPr sz="2000" b="0">
-                <a:solidFill>
-                  <a:srgbClr val="262B30"/>
-                </a:solidFill>
-                <a:latin typeface="Arial"/>
-              </a:rPr>
-              <a:t>Schedule</a:t>
-            </a:r>
-          </a:p>
-        </p:txBody>
-      </p:sp>
-      <p:sp>
-        <p:nvSpPr>
-          <p:cNvPr id="71" name="TOC number 7"/>
-          <p:cNvSpPr/>
-          <p:nvPr/>
-        </p:nvSpPr>
-        <p:spPr>
-          <a:xfrm>
-            <a:off x="900000" y="5040000"/>
-            <a:ext cx="520000" cy="520000"/>
-          </a:xfrm>
-          <a:prstGeom prst="ellipse">
-            <a:avLst/>
-          </a:prstGeom>
-          <a:solidFill>
-            <a:srgbClr val="7BCFDF"/>
-          </a:solidFill>
-          <a:ln>
-            <a:noFill/>
-          </a:ln>
-          <a:effectLst/>
-        </p:spPr>
-        <p:style>
-          <a:lnRef idx="1">
-            <a:schemeClr val="accent1"/>
-          </a:lnRef>
-          <a:fillRef idx="3">
-            <a:schemeClr val="accent1"/>
-          </a:fillRef>
-          <a:effectRef idx="2">
-            <a:schemeClr val="accent1"/>
-          </a:effectRef>
-          <a:fontRef idx="minor">
-            <a:schemeClr val="lt1"/>
-          </a:fontRef>
-        </p:style>
-        <p:txBody>
-          <a:bodyPr rtlCol="0" anchor="ctr"/>
-          <a:lstStyle/>
-          <a:p/>
-        </p:txBody>
-      </p:sp>
-      <p:sp>
-        <p:nvSpPr>
-          <p:cNvPr id="72" name="TextBox 71"/>
-          <p:cNvSpPr txBox="1"/>
-          <p:nvPr/>
-        </p:nvSpPr>
-        <p:spPr>
-          <a:xfrm>
-            <a:off x="900000" y="5040000"/>
-            <a:ext cx="520000" cy="520000"/>
-          </a:xfrm>
-          <a:prstGeom prst="rect">
-            <a:avLst/>
-          </a:prstGeom>
-          <a:noFill/>
-        </p:spPr>
-        <p:txBody>
-          <a:bodyPr wrap="square" anchor="ctr" lIns="0" rIns="0" tIns="0" bIns="0">
-            <a:spAutoFit/>
-          </a:bodyPr>
-          <a:lstStyle/>
-          <a:p>
-            <a:pPr algn="ctr">
-              <a:spcAft>
-                <a:spcPts val="0"/>
-              </a:spcAft>
-            </a:pPr>
-            <a:r>
-              <a:rPr sz="1800" b="1">
-                <a:solidFill>
-                  <a:srgbClr val="0F2F46"/>
-                </a:solidFill>
-                <a:latin typeface="Arial"/>
-              </a:rPr>
-              <a:t>7</a:t>
-            </a:r>
-          </a:p>
-        </p:txBody>
-      </p:sp>
-      <p:sp>
-        <p:nvSpPr>
-          <p:cNvPr id="73" name="TextBox 72"/>
-          <p:cNvSpPr txBox="1"/>
-          <p:nvPr/>
-        </p:nvSpPr>
-        <p:spPr>
-          <a:xfrm>
-            <a:off x="1650000" y="5040000"/>
-            <a:ext cx="9000000" cy="520000"/>
-          </a:xfrm>
-          <a:prstGeom prst="rect">
-            <a:avLst/>
-          </a:prstGeom>
-          <a:noFill/>
-        </p:spPr>
-        <p:txBody>
-          <a:bodyPr wrap="square" anchor="ctr" lIns="0" rIns="0" tIns="0" bIns="0">
-            <a:spAutoFit/>
-          </a:bodyPr>
-          <a:lstStyle/>
-          <a:p>
-            <a:pPr algn="l">
-              <a:spcAft>
-                <a:spcPts val="0"/>
-              </a:spcAft>
-            </a:pPr>
-            <a:r>
-              <a:rPr sz="2000" b="0">
-                <a:solidFill>
-                  <a:srgbClr val="262B30"/>
-                </a:solidFill>
-                <a:latin typeface="Arial"/>
-              </a:rPr>
-              <a:t>Participants</a:t>
-            </a:r>
-          </a:p>
-        </p:txBody>
-      </p:sp>
-      <p:sp>
-        <p:nvSpPr>
-          <p:cNvPr id="74" name="TOC number 8"/>
-          <p:cNvSpPr/>
-          <p:nvPr/>
-        </p:nvSpPr>
-        <p:spPr>
-          <a:xfrm>
-            <a:off x="900000" y="5640000"/>
-            <a:ext cx="520000" cy="520000"/>
-          </a:xfrm>
-          <a:prstGeom prst="ellipse">
-            <a:avLst/>
-          </a:prstGeom>
-          <a:solidFill>
-            <a:srgbClr val="0F2F46"/>
-          </a:solidFill>
-          <a:ln>
-            <a:noFill/>
-          </a:ln>
-          <a:effectLst/>
-        </p:spPr>
-        <p:style>
-          <a:lnRef idx="1">
-            <a:schemeClr val="accent1"/>
-          </a:lnRef>
-          <a:fillRef idx="3">
-            <a:schemeClr val="accent1"/>
-          </a:fillRef>
-          <a:effectRef idx="2">
-            <a:schemeClr val="accent1"/>
-          </a:effectRef>
-          <a:fontRef idx="minor">
-            <a:schemeClr val="lt1"/>
-          </a:fontRef>
-        </p:style>
-        <p:txBody>
-          <a:bodyPr rtlCol="0" anchor="ctr"/>
-          <a:lstStyle/>
-          <a:p/>
-        </p:txBody>
-      </p:sp>
-      <p:sp>
-        <p:nvSpPr>
-          <p:cNvPr id="75" name="TextBox 74"/>
-          <p:cNvSpPr txBox="1"/>
-          <p:nvPr/>
-        </p:nvSpPr>
-        <p:spPr>
-          <a:xfrm>
-            <a:off x="900000" y="5640000"/>
-            <a:ext cx="520000" cy="520000"/>
-          </a:xfrm>
-          <a:prstGeom prst="rect">
-            <a:avLst/>
-          </a:prstGeom>
-          <a:noFill/>
-        </p:spPr>
-        <p:txBody>
-          <a:bodyPr wrap="square" anchor="ctr" lIns="0" rIns="0" tIns="0" bIns="0">
-            <a:spAutoFit/>
-          </a:bodyPr>
-          <a:lstStyle/>
-          <a:p>
-            <a:pPr algn="ctr">
-              <a:spcAft>
-                <a:spcPts val="0"/>
-              </a:spcAft>
-            </a:pPr>
-            <a:r>
-              <a:rPr sz="1800" b="1">
-                <a:solidFill>
-                  <a:srgbClr val="FFFFFF"/>
-                </a:solidFill>
-                <a:latin typeface="Arial"/>
-              </a:rPr>
-              <a:t>8</a:t>
-            </a:r>
-          </a:p>
-        </p:txBody>
-      </p:sp>
-      <p:sp>
-        <p:nvSpPr>
-          <p:cNvPr id="76" name="TextBox 75"/>
-          <p:cNvSpPr txBox="1"/>
-          <p:nvPr/>
-        </p:nvSpPr>
-        <p:spPr>
-          <a:xfrm>
-            <a:off x="1650000" y="5640000"/>
-            <a:ext cx="9000000" cy="520000"/>
-          </a:xfrm>
-          <a:prstGeom prst="rect">
-            <a:avLst/>
-          </a:prstGeom>
-          <a:noFill/>
-        </p:spPr>
-        <p:txBody>
-          <a:bodyPr wrap="square" anchor="ctr" lIns="0" rIns="0" tIns="0" bIns="0">
-            <a:spAutoFit/>
-          </a:bodyPr>
-          <a:lstStyle/>
-          <a:p>
-            <a:pPr algn="l">
-              <a:spcAft>
-                <a:spcPts val="0"/>
-              </a:spcAft>
-            </a:pPr>
-            <a:r>
-              <a:rPr sz="2000" b="0">
-                <a:solidFill>
-                  <a:srgbClr val="262B30"/>
-                </a:solidFill>
-                <a:latin typeface="Arial"/>
-              </a:rPr>
-              <a:t>Budget</a:t>
-            </a:r>
-          </a:p>
-        </p:txBody>
-      </p:sp>
-      <p:sp>
-        <p:nvSpPr>
-          <p:cNvPr id="77" name="TOC number 9"/>
-          <p:cNvSpPr/>
-          <p:nvPr/>
-        </p:nvSpPr>
-        <p:spPr>
-          <a:xfrm>
-            <a:off x="900000" y="6240000"/>
-            <a:ext cx="520000" cy="520000"/>
-          </a:xfrm>
-          <a:prstGeom prst="ellipse">
-            <a:avLst/>
-          </a:prstGeom>
-          <a:solidFill>
-            <a:srgbClr val="7BCFDF"/>
-          </a:solidFill>
-          <a:ln>
-            <a:noFill/>
-          </a:ln>
-          <a:effectLst/>
-        </p:spPr>
-        <p:style>
-          <a:lnRef idx="1">
-            <a:schemeClr val="accent1"/>
-          </a:lnRef>
-          <a:fillRef idx="3">
-            <a:schemeClr val="accent1"/>
-          </a:fillRef>
-          <a:effectRef idx="2">
-            <a:schemeClr val="accent1"/>
-          </a:effectRef>
-          <a:fontRef idx="minor">
-            <a:schemeClr val="lt1"/>
-          </a:fontRef>
-        </p:style>
-        <p:txBody>
-          <a:bodyPr rtlCol="0" anchor="ctr"/>
-          <a:lstStyle/>
-          <a:p/>
-        </p:txBody>
-      </p:sp>
-      <p:sp>
-        <p:nvSpPr>
-          <p:cNvPr id="78" name="TextBox 77"/>
-          <p:cNvSpPr txBox="1"/>
-          <p:nvPr/>
-        </p:nvSpPr>
-        <p:spPr>
-          <a:xfrm>
-            <a:off x="900000" y="6240000"/>
-            <a:ext cx="520000" cy="520000"/>
-          </a:xfrm>
-          <a:prstGeom prst="rect">
-            <a:avLst/>
-          </a:prstGeom>
-          <a:noFill/>
-        </p:spPr>
-        <p:txBody>
-          <a:bodyPr wrap="square" anchor="ctr" lIns="0" rIns="0" tIns="0" bIns="0">
-            <a:spAutoFit/>
-          </a:bodyPr>
-          <a:lstStyle/>
-          <a:p>
-            <a:pPr algn="ctr">
-              <a:spcAft>
-                <a:spcPts val="0"/>
-              </a:spcAft>
-            </a:pPr>
-            <a:r>
-              <a:rPr sz="1800" b="1">
-                <a:solidFill>
-                  <a:srgbClr val="0F2F46"/>
-                </a:solidFill>
-                <a:latin typeface="Arial"/>
-              </a:rPr>
-              <a:t>9</a:t>
-            </a:r>
-          </a:p>
-        </p:txBody>
-      </p:sp>
-      <p:sp>
-        <p:nvSpPr>
-          <p:cNvPr id="79" name="TextBox 78"/>
-          <p:cNvSpPr txBox="1"/>
-          <p:nvPr/>
-        </p:nvSpPr>
-        <p:spPr>
-          <a:xfrm>
-            <a:off x="1650000" y="6240000"/>
-            <a:ext cx="9000000" cy="520000"/>
-          </a:xfrm>
-          <a:prstGeom prst="rect">
-            <a:avLst/>
-          </a:prstGeom>
-          <a:noFill/>
-        </p:spPr>
-        <p:txBody>
-          <a:bodyPr wrap="square" anchor="ctr" lIns="0" rIns="0" tIns="0" bIns="0">
-            <a:spAutoFit/>
-          </a:bodyPr>
-          <a:lstStyle/>
-          <a:p>
-            <a:pPr algn="l">
-              <a:spcAft>
-                <a:spcPts val="0"/>
-              </a:spcAft>
-            </a:pPr>
-            <a:r>
-              <a:rPr sz="2000" b="0">
-                <a:solidFill>
-                  <a:srgbClr val="262B30"/>
-                </a:solidFill>
-                <a:latin typeface="Arial"/>
-              </a:rPr>
-              <a:t>Items to confirm</a:t>
-            </a:r>
-          </a:p>
-        </p:txBody>
-      </p:sp>
-    </p:spTree>
-  </p:cSld>
-  <p:clrMapOvr>
-    <a:masterClrMapping/>
-  </p:clrMapOvr>
-</p:sld>
-</file>
-
-<file path=ppt/slides/slide20.xml><?xml version="1.0" encoding="utf-8"?>
+<file path=ppt/slides/slide22.xml><?xml version="1.0" encoding="utf-8"?>
 <p:sld xmlns:a="http://schemas.openxmlformats.org/drawingml/2006/main" xmlns:r="http://schemas.openxmlformats.org/officeDocument/2006/relationships" xmlns:mc="http://schemas.openxmlformats.org/markup-compatibility/2006" xmlns:mv="urn:schemas-microsoft-com:mac:vml" xmlns:p="http://schemas.openxmlformats.org/presentationml/2006/main" xmlns:c="http://schemas.openxmlformats.org/drawingml/2006/chart" xmlns:dgm="http://schemas.openxmlformats.org/drawingml/2006/diagram" xmlns:o="urn:schemas-microsoft-com:office:office" xmlns:v="urn:schemas-microsoft-com:vml" xmlns:pvml="urn:schemas-microsoft-com:office:powerpoint" xmlns:com="http://schemas.openxmlformats.org/drawingml/2006/compatibility" xmlns:p14="http://schemas.microsoft.com/office/powerpoint/2010/main" xmlns:p15="http://schemas.microsoft.com/office/powerpoint/2012/main" xmlns:ahyp="http://schemas.microsoft.com/office/drawing/2018/hyperlinkcolor">
   <p:cSld>
     <p:spTree>
@@ -18418,7 +19680,24 @@
                 </a:solidFill>
                 <a:latin typeface="Arial"/>
               </a:rPr>
-              <a:t>16 checkpoints, photo missions and the stamp rally on the server</a:t>
+              <a:t>15 new spots, photo missions and the stamp rally on the server; missions on the 16 checkpoints only</a:t>
+            </a:r>
+          </a:p>
+          <a:p>
+            <a:pPr algn="l" marL="228600" indent="-228600">
+              <a:spcAft>
+                <a:spcPts val="1000"/>
+              </a:spcAft>
+              <a:buChar char="•"/>
+            </a:pPr>
+            <a:r>
+              <a:rPr sz="1800" b="0">
+                <a:solidFill>
+                  <a:srgbClr val="FFFFFF"/>
+                </a:solidFill>
+                <a:latin typeface="Arial"/>
+              </a:rPr>
+              <a:t>Hide other app spots (Skytree, Hanayashiki, etc.) during the experiment, if possible</a:t>
             </a:r>
           </a:p>
           <a:p>
@@ -21423,7 +22702,7 @@
                 </a:solidFill>
                 <a:latin typeface="Arial"/>
               </a:rPr>
-              <a:t>Orange = popular. Reviews and ratings: Google Maps, 13 Oct 2026. "From start" = straight-line distance from the Asakusa Culture Tourist Information Center.</a:t>
+              <a:t>Orange = popular. Only Sensō-ji is already in the app (ID 1041). Reviews and ratings: Google Maps, 13 Oct 2026. "From start" = straight-line distance from the Asakusa Culture Tourist Information Center.</a:t>
             </a:r>
           </a:p>
         </p:txBody>
@@ -23294,7 +24573,7 @@
                 </a:solidFill>
                 <a:latin typeface="Arial"/>
               </a:rPr>
-              <a:t>Orange = popular. Reviews and ratings: Google Maps, 13 Oct 2026. "From start" = straight-line distance from the Asakusa Culture Tourist Information Center.</a:t>
+              <a:t>Orange = popular. Only Sensō-ji is already in the app (ID 1041). Reviews and ratings: Google Maps, 13 Oct 2026. "From start" = straight-line distance from the Asakusa Culture Tourist Information Center.</a:t>
             </a:r>
           </a:p>
         </p:txBody>

</xml_diff>